<commit_message>
feat: add downloadable 12-slide PowerPoint (.pptx) pitch deck
</commit_message>
<xml_diff>
--- a/public/EIMS_ProSystem_Pitch_Deck.pptx
+++ b/public/EIMS_ProSystem_Pitch_Deck.pptx
@@ -405,7 +405,7 @@
                 </a:solidFill>
                 <a:latin typeface="Arial"/>
               </a:rPr>
-              <a:t>5 Core Design Decisions</a:t>
+              <a:t>6 Core Design Decisions</a:t>
             </a:r>
           </a:p>
         </p:txBody>
@@ -492,7 +492,7 @@
                 </a:solidFill>
                 <a:latin typeface="Arial"/>
               </a:rPr>
-              <a:t>4 Roles &amp; 24 Portal Modules</a:t>
+              <a:t>7 Domains &amp; 25 Modules</a:t>
             </a:r>
           </a:p>
         </p:txBody>
@@ -543,7 +543,7 @@
                 </a:solidFill>
                 <a:latin typeface="Arial"/>
               </a:rPr>
-              <a:t>FNOL Triage &amp; GIS Telemetry</a:t>
+              <a:t>Claim Alerts &amp; 60m Red SLA</a:t>
             </a:r>
           </a:p>
         </p:txBody>
@@ -594,7 +594,7 @@
                 </a:solidFill>
                 <a:latin typeface="Arial"/>
               </a:rPr>
-              <a:t>5-Stage Garage &amp; Subrogation</a:t>
+              <a:t>Underwriting Email &amp; EV Desk</a:t>
             </a:r>
           </a:p>
         </p:txBody>
@@ -645,7 +645,7 @@
                 </a:solidFill>
                 <a:latin typeface="Arial"/>
               </a:rPr>
-              <a:t>3-Sticker AKI QR Certificate</a:t>
+              <a:t>Garages, Subrogation &amp; QR</a:t>
             </a:r>
           </a:p>
         </p:txBody>
@@ -732,7 +732,7 @@
                 </a:solidFill>
                 <a:latin typeface="Arial"/>
               </a:rPr>
-              <a:t>4-Layer Cloud Architecture</a:t>
+              <a:t>4-Layer Cloud &amp; Telemetry</a:t>
             </a:r>
           </a:p>
         </p:txBody>
@@ -783,7 +783,7 @@
                 </a:solidFill>
                 <a:latin typeface="Arial"/>
               </a:rPr>
-              <a:t>Zero-Trust &amp; Cap 487 Model</a:t>
+              <a:t>Zero-Trust &amp; Cap 487 Tax</a:t>
             </a:r>
           </a:p>
         </p:txBody>
@@ -834,7 +834,7 @@
                 </a:solidFill>
                 <a:latin typeface="Arial"/>
               </a:rPr>
-              <a:t>Governance &amp; 4 Licensing Tiers</a:t>
+              <a:t>Reinsurance &amp; Pricing Tiers</a:t>
             </a:r>
           </a:p>
         </p:txBody>
@@ -870,7 +870,7 @@
                 </a:solidFill>
                 <a:latin typeface="Arial"/>
               </a:rPr>
-              <a:t>IV. AI, ROADMAP &amp; IMPACT</a:t>
+              <a:t>IV. AI, GOD MODE &amp; IMPACT</a:t>
             </a:r>
           </a:p>
         </p:txBody>
@@ -921,7 +921,7 @@
                 </a:solidFill>
                 <a:latin typeface="Arial"/>
               </a:rPr>
-              <a:t>Gemini AI Copilot &amp; Guardrails</a:t>
+              <a:t>Reports AI Analytics Tool</a:t>
             </a:r>
           </a:p>
         </p:txBody>
@@ -972,7 +972,7 @@
                 </a:solidFill>
                 <a:latin typeface="Arial"/>
               </a:rPr>
-              <a:t>36-Mo Roadmap &amp; Targets</a:t>
+              <a:t>God Mode &amp; 36-Mo Roadmap</a:t>
             </a:r>
           </a:p>
         </p:txBody>
@@ -1050,7 +1050,7 @@
                 </a:solidFill>
                 <a:latin typeface="Arial"/>
               </a:rPr>
-              <a:t>Next-Gen Autonomous Fleet &amp; General Insurance Infrastructure</a:t>
+              <a:t>Self-Improving Autonomous Fleet &amp; General Insurance OS</a:t>
             </a:r>
           </a:p>
           <a:p>
@@ -1066,7 +1066,7 @@
                 </a:solidFill>
                 <a:latin typeface="Arial"/>
               </a:rPr>
-              <a:t>Transforming Kenyan county &amp; commercial fleet underwriting, computer-vision FNOL claims triage, AKI digital motor certification, and sub-30-second multi-channel settlements.</a:t>
+              <a:t>Unifying Kenyan county &amp; commercial fleet underwriting, computer-vision FNOL claims triage, automated designated email alerts, 60-minute Red SLA escalation, Reports AI Analytics, and God Mode continuous self-improvement.</a:t>
             </a:r>
           </a:p>
         </p:txBody>
@@ -1108,7 +1108,7 @@
                 </a:solidFill>
                 <a:latin typeface="Arial"/>
               </a:rPr>
-              <a:t>KSh 37.28M</a:t>
+              <a:t>25 Modules</a:t>
             </a:r>
           </a:p>
           <a:p>
@@ -1124,7 +1124,7 @@
                 </a:solidFill>
                 <a:latin typeface="Arial"/>
               </a:rPr>
-              <a:t>GROSS UNDERWRITTEN PREMIUM</a:t>
+              <a:t>ACROSS 7 ENTERPRISE DOMAINS</a:t>
             </a:r>
           </a:p>
         </p:txBody>
@@ -1166,7 +1166,7 @@
                 </a:solidFill>
                 <a:latin typeface="Arial"/>
               </a:rPr>
-              <a:t>92%</a:t>
+              <a:t>60-Min SLA</a:t>
             </a:r>
           </a:p>
           <a:p>
@@ -1182,7 +1182,7 @@
                 </a:solidFill>
                 <a:latin typeface="Arial"/>
               </a:rPr>
-              <a:t>AUTO-PASS GREEN PATH ACCURACY</a:t>
+              <a:t>RED DASHBOARD &amp; EMAIL ALERTS</a:t>
             </a:r>
           </a:p>
         </p:txBody>
@@ -1224,7 +1224,7 @@
                 </a:solidFill>
                 <a:latin typeface="Arial"/>
               </a:rPr>
-              <a:t>429</a:t>
+              <a:t>99.42%</a:t>
             </a:r>
           </a:p>
           <a:p>
@@ -1240,7 +1240,7 @@
                 </a:solidFill>
                 <a:latin typeface="Arial"/>
               </a:rPr>
-              <a:t>ACTIVE COUNTY &amp; FLEET POLICIES</a:t>
+              <a:t>GOD MODE AI PRECISION</a:t>
             </a:r>
           </a:p>
         </p:txBody>
@@ -1340,7 +1340,7 @@
                 </a:solidFill>
                 <a:latin typeface="Courier New"/>
               </a:rPr>
-              <a:t>NATIONAL SCOPE</a:t>
+              <a:t>NATIONAL SCOPE &amp; 25 MODULES</a:t>
             </a:r>
           </a:p>
           <a:p>
@@ -1356,7 +1356,7 @@
                 </a:solidFill>
                 <a:latin typeface="Arial"/>
               </a:rPr>
-              <a:t>Built for Kenya's 47 Counties &amp; Commercial Fleets</a:t>
+              <a:t>Built for Kenya's 47 Counties, EVs &amp; Commercial Fleets</a:t>
             </a:r>
           </a:p>
           <a:p>
@@ -1372,7 +1372,7 @@
                 </a:solidFill>
                 <a:latin typeface="Arial"/>
               </a:rPr>
-              <a:t>Unified underwriting and claims command platform purpose-built for county government fleets, electric vehicles (EV), motor comprehensive, and non-motor lines across Nairobi HQ, Mombasa, Kisumu, and Nakuru.</a:t>
+              <a:t>Unified underwriting and claims command platform across Nairobi HQ, Mombasa, Kisumu, Nakuru, and Eldoret—featuring instant quick-jump navigation across 25 specialized operational sub-modules.</a:t>
             </a:r>
           </a:p>
         </p:txBody>
@@ -1414,7 +1414,7 @@
                 </a:solidFill>
                 <a:latin typeface="Courier New"/>
               </a:rPr>
-              <a:t>REGULATORY NATIVE</a:t>
+              <a:t>PROACTIVE EMAIL &amp; 60-MIN SLA GUARD</a:t>
             </a:r>
           </a:p>
           <a:p>
@@ -1430,7 +1430,7 @@
                 </a:solidFill>
                 <a:latin typeface="Arial"/>
               </a:rPr>
-              <a:t>IRA Cap 487, Cap 405 &amp; KRA eTIMS Compliant</a:t>
+              <a:t>Automated Designated Email Alerts &amp; Red Dashboard SLA</a:t>
             </a:r>
           </a:p>
           <a:p>
@@ -1446,7 +1446,7 @@
                 </a:solidFill>
                 <a:latin typeface="Arial"/>
               </a:rPr>
-              <a:t>Native statutory computation of PHCF (0.25%), Insurance Training Levy (0.20%), Stamp Duty (KSh 40), KRA 16% VAT / 5% WHT, KIRA Form 104 filings, and AKI scannable 3-part digital certificates.</a:t>
+              <a:t>Every new Claim ('Awaiting Approval') and New Policy Underwriting immediately dispatches rich HTML email notifications to designated approvers, escalating in crimson RED on the Dashboard if pending &gt;60 minutes.</a:t>
             </a:r>
           </a:p>
         </p:txBody>
@@ -1488,7 +1488,7 @@
                 </a:solidFill>
                 <a:latin typeface="Courier New"/>
               </a:rPr>
-              <a:t>AI &amp; TELEMETRY FIRST</a:t>
+              <a:t>AI ANALYTICS &amp; GOD MODE KERNEL</a:t>
             </a:r>
           </a:p>
           <a:p>
@@ -1504,7 +1504,7 @@
                 </a:solidFill>
                 <a:latin typeface="Arial"/>
               </a:rPr>
-              <a:t>EXIF Scene Forensics &amp; Google Gemini Copilot</a:t>
+              <a:t>Predictive Actuarial BI + Autonomous Self-Improvement</a:t>
             </a:r>
           </a:p>
           <a:p>
@@ -1520,7 +1520,7 @@
                 </a:solidFill>
                 <a:latin typeface="Arial"/>
               </a:rPr>
-              <a:t>Every accident claim is cross-referenced against camera GPS EXIF coordinates, NTSA ANPR plate lookup, and an embedded Google Gemini 2.5 Flash executive synthesizer.</a:t>
+              <a:t>Combines an embedded Neural BI Engine v4.2 under Reports (90-day GWP/Loss-Ratio forecasting &amp; fraud drift scan) with God Mode (Autonomous Kernel v9.4) that continuously self-tunes tariffs and heals DOM invariants.</a:t>
             </a:r>
           </a:p>
         </p:txBody>
@@ -1909,7 +1909,7 @@
                 </a:solidFill>
                 <a:latin typeface="Arial"/>
               </a:rPr>
-              <a:t>5 Core Design Decisions</a:t>
+              <a:t>6 Core Design Decisions</a:t>
             </a:r>
           </a:p>
         </p:txBody>
@@ -1996,7 +1996,7 @@
                 </a:solidFill>
                 <a:latin typeface="Arial"/>
               </a:rPr>
-              <a:t>4 Roles &amp; 24 Portal Modules</a:t>
+              <a:t>7 Domains &amp; 25 Modules</a:t>
             </a:r>
           </a:p>
         </p:txBody>
@@ -2047,7 +2047,7 @@
                 </a:solidFill>
                 <a:latin typeface="Arial"/>
               </a:rPr>
-              <a:t>FNOL Triage &amp; GIS Telemetry</a:t>
+              <a:t>Claim Alerts &amp; 60m Red SLA</a:t>
             </a:r>
           </a:p>
         </p:txBody>
@@ -2098,7 +2098,7 @@
                 </a:solidFill>
                 <a:latin typeface="Arial"/>
               </a:rPr>
-              <a:t>5-Stage Garage &amp; Subrogation</a:t>
+              <a:t>Underwriting Email &amp; EV Desk</a:t>
             </a:r>
           </a:p>
         </p:txBody>
@@ -2149,7 +2149,7 @@
                 </a:solidFill>
                 <a:latin typeface="Arial"/>
               </a:rPr>
-              <a:t>3-Sticker AKI QR Certificate</a:t>
+              <a:t>Garages, Subrogation &amp; QR</a:t>
             </a:r>
           </a:p>
         </p:txBody>
@@ -2236,7 +2236,7 @@
                 </a:solidFill>
                 <a:latin typeface="Arial"/>
               </a:rPr>
-              <a:t>4-Layer Cloud Architecture</a:t>
+              <a:t>4-Layer Cloud &amp; Telemetry</a:t>
             </a:r>
           </a:p>
         </p:txBody>
@@ -2287,7 +2287,7 @@
                 </a:solidFill>
                 <a:latin typeface="Arial"/>
               </a:rPr>
-              <a:t>Zero-Trust &amp; Cap 487 Model</a:t>
+              <a:t>Zero-Trust &amp; Cap 487 Tax</a:t>
             </a:r>
           </a:p>
         </p:txBody>
@@ -2338,7 +2338,7 @@
                 </a:solidFill>
                 <a:latin typeface="Arial"/>
               </a:rPr>
-              <a:t>Governance &amp; 4 Licensing Tiers</a:t>
+              <a:t>Reinsurance &amp; Pricing Tiers</a:t>
             </a:r>
           </a:p>
         </p:txBody>
@@ -2374,7 +2374,7 @@
                 </a:solidFill>
                 <a:latin typeface="Arial"/>
               </a:rPr>
-              <a:t>IV. AI, ROADMAP &amp; IMPACT</a:t>
+              <a:t>IV. AI, GOD MODE &amp; IMPACT</a:t>
             </a:r>
           </a:p>
         </p:txBody>
@@ -2425,7 +2425,7 @@
                 </a:solidFill>
                 <a:latin typeface="Arial"/>
               </a:rPr>
-              <a:t>Gemini AI Copilot &amp; Guardrails</a:t>
+              <a:t>Reports AI Analytics Tool</a:t>
             </a:r>
           </a:p>
         </p:txBody>
@@ -2476,7 +2476,7 @@
                 </a:solidFill>
                 <a:latin typeface="Arial"/>
               </a:rPr>
-              <a:t>36-Mo Roadmap &amp; Targets</a:t>
+              <a:t>God Mode &amp; 36-Mo Roadmap</a:t>
             </a:r>
           </a:p>
         </p:txBody>
@@ -2518,7 +2518,7 @@
                 </a:solidFill>
                 <a:latin typeface="Arial"/>
               </a:rPr>
-              <a:t>SLIDE 10 · GOVERNANCE &amp; 4 LICENSING TIERS</a:t>
+              <a:t>SLIDE 10 · REINSURANCE &amp; PRICING TIERS</a:t>
             </a:r>
           </a:p>
         </p:txBody>
@@ -2554,7 +2554,7 @@
                 </a:solidFill>
                 <a:latin typeface="Arial"/>
               </a:rPr>
-              <a:t>Multi-Branch Seat Governance, Reinsurance &amp; SaaS Tiers</a:t>
+              <a:t>3-Reinsurer Treaty Ceding &amp; Enterprise Subscription Tiers</a:t>
             </a:r>
           </a:p>
           <a:p>
@@ -2570,7 +2570,7 @@
                 </a:solidFill>
                 <a:latin typeface="Arial"/>
               </a:rPr>
-              <a:t>Scalable enterprise licensing, 3-reinsurer quota share risk allocation, and live remote staff productivity monitoring.</a:t>
+              <a:t>Transparent seat-based SaaS licensing for agencies, multi-branch underwriters, and national county fleets, backed by automated reinsurance risk splitting.</a:t>
             </a:r>
           </a:p>
         </p:txBody>
@@ -2612,7 +2612,7 @@
                 </a:solidFill>
                 <a:latin typeface="Arial"/>
               </a:rPr>
-              <a:t>4 Tiers</a:t>
+              <a:t>KSh 269K</a:t>
             </a:r>
           </a:p>
           <a:p>
@@ -2628,7 +2628,7 @@
                 </a:solidFill>
                 <a:latin typeface="Arial"/>
               </a:rPr>
-              <a:t>STARTER, COUNTY, ENTERPRISE, NAT</a:t>
+              <a:t>STARTER TIER (UP TO 5 SEATS)</a:t>
             </a:r>
           </a:p>
         </p:txBody>
@@ -2670,7 +2670,7 @@
                 </a:solidFill>
                 <a:latin typeface="Arial"/>
               </a:rPr>
-              <a:t>3 Reinsurers</a:t>
+              <a:t>KSh 349K</a:t>
             </a:r>
           </a:p>
           <a:p>
@@ -2686,7 +2686,7 @@
                 </a:solidFill>
                 <a:latin typeface="Arial"/>
               </a:rPr>
-              <a:t>KENYA RE, ZEP-RE, AFRICA RE</a:t>
+              <a:t>PROFESSIONAL TIER (25 SEATS)</a:t>
             </a:r>
           </a:p>
         </p:txBody>
@@ -2728,7 +2728,7 @@
                 </a:solidFill>
                 <a:latin typeface="Arial"/>
               </a:rPr>
-              <a:t>25% Retention</a:t>
+              <a:t>KSh 599K</a:t>
             </a:r>
           </a:p>
           <a:p>
@@ -2744,7 +2744,7 @@
                 </a:solidFill>
                 <a:latin typeface="Arial"/>
               </a:rPr>
-              <a:t>DYNAMIC NET RISK RETENTION</a:t>
+              <a:t>ENTERPRISE TIER (UNLIMITED)</a:t>
             </a:r>
           </a:p>
         </p:txBody>
@@ -2786,7 +2786,7 @@
                 </a:solidFill>
                 <a:latin typeface="Arial"/>
               </a:rPr>
-              <a:t>RBAC Seats</a:t>
+              <a:t>50 / 30 / 20</a:t>
             </a:r>
           </a:p>
           <a:p>
@@ -2802,7 +2802,7 @@
                 </a:solidFill>
                 <a:latin typeface="Arial"/>
               </a:rPr>
-              <a:t>BRANCH &amp; ROLE PROVISIONING</a:t>
+              <a:t>RETENTION / KENYA RE / SURPLUS</a:t>
             </a:r>
           </a:p>
         </p:txBody>
@@ -2844,7 +2844,7 @@
                 </a:solidFill>
                 <a:latin typeface="Courier New"/>
               </a:rPr>
-              <a:t>REINSURANCE TREATY ALLOCATOR</a:t>
+              <a:t>3-REINSURER QUOTA SHARE &amp; SURPLUS ENGINE</a:t>
             </a:r>
           </a:p>
           <a:p>
@@ -2860,7 +2860,7 @@
                 </a:solidFill>
                 <a:latin typeface="Arial"/>
               </a:rPr>
-              <a:t>3-Reinsurer Quota Share Risk Ceding Engine</a:t>
+              <a:t>Automated Treaty Ceding Across Gross Exposure</a:t>
             </a:r>
           </a:p>
           <a:p>
@@ -2876,7 +2876,7 @@
                 </a:solidFill>
                 <a:latin typeface="Arial"/>
               </a:rPr>
-              <a:t>Interactive treaty calculator dynamically splitting gross exposure across Kenya Reinsurance Corp (35% statutory), ZEP-RE PTA (25%), Africa Re (15%), and EIMS Net Retention (25%).</a:t>
+              <a:t>Dynamically allocates risk across EIMS Net Retention (50%), Kenya Reinsurance Corp Mandatory Quota Share (30%), and ZEP-RE / Africa Re Surplus (20%), plus Working Excess of Loss (XOL) above KSh 15M.</a:t>
             </a:r>
           </a:p>
         </p:txBody>
@@ -2918,7 +2918,7 @@
                 </a:solidFill>
                 <a:latin typeface="Courier New"/>
               </a:rPr>
-              <a:t>4 COMMERCIAL LICENSING TIERS</a:t>
+              <a:t>3 COMMERCIAL SUBSCRIPTION TIERS</a:t>
             </a:r>
           </a:p>
           <a:p>
@@ -2934,7 +2934,7 @@
                 </a:solidFill>
                 <a:latin typeface="Arial"/>
               </a:rPr>
-              <a:t>Modular SaaS &amp; County Enterprise Subscriptions</a:t>
+              <a:t>Differentiated by User Seat Capacity &amp; AI Access</a:t>
             </a:r>
           </a:p>
           <a:p>
@@ -2950,7 +2950,7 @@
                 </a:solidFill>
                 <a:latin typeface="Arial"/>
               </a:rPr>
-              <a:t>• Tier 1: Agency Broker Starter (Up to 10 seats)</a:t>
+              <a:t>• Starter (KSh 269,000/mo): Up to 5 seats, 50 policies, standard FNOL.</a:t>
             </a:r>
           </a:p>
           <a:p>
@@ -2966,7 +2966,7 @@
                 </a:solidFill>
                 <a:latin typeface="Arial"/>
               </a:rPr>
-              <a:t>• Tier 2: County Fleet Standard (ANPR + GIS + 50 seats)</a:t>
+              <a:t>• Professional (KSh 349,000/mo): Up to 25 seats, 500 policies, ANPR OCR, AKI QR, M-PESA B2C.</a:t>
             </a:r>
           </a:p>
           <a:p>
@@ -2982,7 +2982,65 @@
                 </a:solidFill>
                 <a:latin typeface="Arial"/>
               </a:rPr>
-              <a:t>• Tier 3: Enterprise Underwriter (Full 24 modules + Gemini AI)</a:t>
+              <a:t>• Enterprise (KSh 599,000/mo): Unlimited seats, 47-County Fleet, Reinsurance, AI Analytics &amp; God Mode.</a:t>
+            </a:r>
+          </a:p>
+        </p:txBody>
+      </p:sp>
+      <p:sp>
+        <p:nvSpPr>
+          <p:cNvPr id="29" name="Card_2"/>
+          <p:cNvSpPr/>
+          <p:nvPr/>
+        </p:nvSpPr>
+        <p:spPr>
+          <a:xfrm>
+            <a:off x="9100000" y="3240000"/>
+            <a:ext cx="2720000" cy="2850000"/>
+          </a:xfrm>
+          <a:prstGeom prst="roundRect">
+            <a:avLst>
+              <a:gd name="adj" fmla="val 8000"/>
+            </a:avLst>
+          </a:prstGeom>
+          <a:solidFill>
+            <a:srgbClr val="110E0B"/>
+          </a:solidFill>
+          <a:ln w="12700">
+            <a:solidFill>
+              <a:srgbClr val="45270A"/>
+            </a:solidFill>
+          </a:ln>
+        </p:spPr>
+        <p:txBody>
+          <a:bodyPr wrap="square" lIns="114300" tIns="91440" rIns="114300" bIns="91440" anchor="t"/>
+          <a:lstStyle/>
+          <a:p>
+            <a:pPr algn="l"/>
+            <a:r>
+              <a:rPr lang="en-US" sz="800" b="1" dirty="0">
+                <a:solidFill>
+                  <a:srgbClr val="F59E0B"/>
+                </a:solidFill>
+                <a:latin typeface="Courier New"/>
+              </a:rPr>
+              <a:t>REMOTE STAFF (WFH) SURVEILLANCE CONSOLE</a:t>
+            </a:r>
+          </a:p>
+          <a:p>
+            <a:pPr algn="l">
+              <a:spcBef>
+                <a:spcPts val="400"/>
+              </a:spcBef>
+            </a:pPr>
+            <a:r>
+              <a:rPr lang="en-US" sz="1250" b="1" dirty="0">
+                <a:solidFill>
+                  <a:srgbClr val="FFFFFF"/>
+                </a:solidFill>
+                <a:latin typeface="Arial"/>
+              </a:rPr>
+              <a:t>Live Session Telemetry &amp; Productivity Pulse Checks</a:t>
             </a:r>
           </a:p>
           <a:p>
@@ -2998,81 +3056,7 @@
                 </a:solidFill>
                 <a:latin typeface="Arial"/>
               </a:rPr>
-              <a:t>• Tier 4: National Multi-Branch Unlimited</a:t>
-            </a:r>
-          </a:p>
-        </p:txBody>
-      </p:sp>
-      <p:sp>
-        <p:nvSpPr>
-          <p:cNvPr id="29" name="Card_2"/>
-          <p:cNvSpPr/>
-          <p:nvPr/>
-        </p:nvSpPr>
-        <p:spPr>
-          <a:xfrm>
-            <a:off x="9100000" y="3240000"/>
-            <a:ext cx="2720000" cy="2850000"/>
-          </a:xfrm>
-          <a:prstGeom prst="roundRect">
-            <a:avLst>
-              <a:gd name="adj" fmla="val 8000"/>
-            </a:avLst>
-          </a:prstGeom>
-          <a:solidFill>
-            <a:srgbClr val="110E0B"/>
-          </a:solidFill>
-          <a:ln w="12700">
-            <a:solidFill>
-              <a:srgbClr val="45270A"/>
-            </a:solidFill>
-          </a:ln>
-        </p:spPr>
-        <p:txBody>
-          <a:bodyPr wrap="square" lIns="114300" tIns="91440" rIns="114300" bIns="91440" anchor="t"/>
-          <a:lstStyle/>
-          <a:p>
-            <a:pPr algn="l"/>
-            <a:r>
-              <a:rPr lang="en-US" sz="800" b="1" dirty="0">
-                <a:solidFill>
-                  <a:srgbClr val="F59E0B"/>
-                </a:solidFill>
-                <a:latin typeface="Courier New"/>
-              </a:rPr>
-              <a:t>REMOTE STAFF &amp; SLA GOVERNANCE</a:t>
-            </a:r>
-          </a:p>
-          <a:p>
-            <a:pPr algn="l">
-              <a:spcBef>
-                <a:spcPts val="400"/>
-              </a:spcBef>
-            </a:pPr>
-            <a:r>
-              <a:rPr lang="en-US" sz="1250" b="1" dirty="0">
-                <a:solidFill>
-                  <a:srgbClr val="FFFFFF"/>
-                </a:solidFill>
-                <a:latin typeface="Arial"/>
-              </a:rPr>
-              <a:t>Live Adjuster Telemetry &amp; Audit Trail</a:t>
-            </a:r>
-          </a:p>
-          <a:p>
-            <a:pPr algn="l">
-              <a:spcBef>
-                <a:spcPts val="500"/>
-              </a:spcBef>
-            </a:pPr>
-            <a:r>
-              <a:rPr lang="en-US" sz="980" b="0" dirty="0">
-                <a:solidFill>
-                  <a:srgbClr val="D4D4D8"/>
-                </a:solidFill>
-                <a:latin typeface="Arial"/>
-              </a:rPr>
-              <a:t>Tracks active staff sessions, claims processed per hour, branch turnaround times, and immutable notification logs across SMS, WhatsApp, and Email channels.</a:t>
+              <a:t>Monitors remote and branch staff sessions, TLS VPN IPs, active claim/underwriting tasks, and productivity pulse scores across Nairobi, Mombasa, Kisumu, and Nakuru.</a:t>
             </a:r>
           </a:p>
         </p:txBody>
@@ -3461,7 +3445,7 @@
                 </a:solidFill>
                 <a:latin typeface="Arial"/>
               </a:rPr>
-              <a:t>5 Core Design Decisions</a:t>
+              <a:t>6 Core Design Decisions</a:t>
             </a:r>
           </a:p>
         </p:txBody>
@@ -3548,7 +3532,7 @@
                 </a:solidFill>
                 <a:latin typeface="Arial"/>
               </a:rPr>
-              <a:t>4 Roles &amp; 24 Portal Modules</a:t>
+              <a:t>7 Domains &amp; 25 Modules</a:t>
             </a:r>
           </a:p>
         </p:txBody>
@@ -3599,7 +3583,7 @@
                 </a:solidFill>
                 <a:latin typeface="Arial"/>
               </a:rPr>
-              <a:t>FNOL Triage &amp; GIS Telemetry</a:t>
+              <a:t>Claim Alerts &amp; 60m Red SLA</a:t>
             </a:r>
           </a:p>
         </p:txBody>
@@ -3650,7 +3634,7 @@
                 </a:solidFill>
                 <a:latin typeface="Arial"/>
               </a:rPr>
-              <a:t>5-Stage Garage &amp; Subrogation</a:t>
+              <a:t>Underwriting Email &amp; EV Desk</a:t>
             </a:r>
           </a:p>
         </p:txBody>
@@ -3701,7 +3685,7 @@
                 </a:solidFill>
                 <a:latin typeface="Arial"/>
               </a:rPr>
-              <a:t>3-Sticker AKI QR Certificate</a:t>
+              <a:t>Garages, Subrogation &amp; QR</a:t>
             </a:r>
           </a:p>
         </p:txBody>
@@ -3788,7 +3772,7 @@
                 </a:solidFill>
                 <a:latin typeface="Arial"/>
               </a:rPr>
-              <a:t>4-Layer Cloud Architecture</a:t>
+              <a:t>4-Layer Cloud &amp; Telemetry</a:t>
             </a:r>
           </a:p>
         </p:txBody>
@@ -3839,7 +3823,7 @@
                 </a:solidFill>
                 <a:latin typeface="Arial"/>
               </a:rPr>
-              <a:t>Zero-Trust &amp; Cap 487 Model</a:t>
+              <a:t>Zero-Trust &amp; Cap 487 Tax</a:t>
             </a:r>
           </a:p>
         </p:txBody>
@@ -3890,7 +3874,7 @@
                 </a:solidFill>
                 <a:latin typeface="Arial"/>
               </a:rPr>
-              <a:t>Governance &amp; 4 Licensing Tiers</a:t>
+              <a:t>Reinsurance &amp; Pricing Tiers</a:t>
             </a:r>
           </a:p>
         </p:txBody>
@@ -3926,7 +3910,7 @@
                 </a:solidFill>
                 <a:latin typeface="Arial"/>
               </a:rPr>
-              <a:t>IV. AI, ROADMAP &amp; IMPACT</a:t>
+              <a:t>IV. AI, GOD MODE &amp; IMPACT</a:t>
             </a:r>
           </a:p>
         </p:txBody>
@@ -3977,7 +3961,7 @@
                 </a:solidFill>
                 <a:latin typeface="Arial"/>
               </a:rPr>
-              <a:t>Gemini AI Copilot &amp; Guardrails</a:t>
+              <a:t>Reports AI Analytics Tool</a:t>
             </a:r>
           </a:p>
         </p:txBody>
@@ -4028,7 +4012,7 @@
                 </a:solidFill>
                 <a:latin typeface="Arial"/>
               </a:rPr>
-              <a:t>36-Mo Roadmap &amp; Targets</a:t>
+              <a:t>God Mode &amp; 36-Mo Roadmap</a:t>
             </a:r>
           </a:p>
         </p:txBody>
@@ -4070,7 +4054,7 @@
                 </a:solidFill>
                 <a:latin typeface="Arial"/>
               </a:rPr>
-              <a:t>SLIDE 11 · GEMINI AI COPILOT &amp; GUARDRAILS</a:t>
+              <a:t>SLIDE 11 · REPORTS AI ANALYTICS TOOL</a:t>
             </a:r>
           </a:p>
         </p:txBody>
@@ -4106,7 +4090,7 @@
                 </a:solidFill>
                 <a:latin typeface="Arial"/>
               </a:rPr>
-              <a:t>Dedicated Google Gemini 2.5 Flash Executive Copilot</a:t>
+              <a:t>Neural BI Engine v4.2 Under Reports &amp; Executive AI Copilot</a:t>
             </a:r>
           </a:p>
           <a:p>
@@ -4122,7 +4106,7 @@
                 </a:solidFill>
                 <a:latin typeface="Arial"/>
               </a:rPr>
-              <a:t>Natural-language executive intelligence grounded strictly in live underwriting, claims, subrogation, and certificate ledgers.</a:t>
+              <a:t>Embedded directly inside Reports &amp; Analytics Query Center for natural-language actuarial queries, 90-day forecasting, anomaly detection, and executive brief export.</a:t>
             </a:r>
           </a:p>
         </p:txBody>
@@ -4164,7 +4148,7 @@
                 </a:solidFill>
                 <a:latin typeface="Arial"/>
               </a:rPr>
-              <a:t>Gemini 2.5</a:t>
+              <a:t>Neural BI v4.2</a:t>
             </a:r>
           </a:p>
           <a:p>
@@ -4180,7 +4164,7 @@
                 </a:solidFill>
                 <a:latin typeface="Arial"/>
               </a:rPr>
-              <a:t>EXECUTIVE REPORT SYNTHESIZER</a:t>
+              <a:t>EMBEDDED INSIDE REPORTS CENTER</a:t>
             </a:r>
           </a:p>
         </p:txBody>
@@ -4222,7 +4206,7 @@
                 </a:solidFill>
                 <a:latin typeface="Arial"/>
               </a:rPr>
-              <a:t>6 Quick Pills</a:t>
+              <a:t>KSh 154.8M</a:t>
             </a:r>
           </a:p>
           <a:p>
@@ -4238,7 +4222,7 @@
                 </a:solidFill>
                 <a:latin typeface="Arial"/>
               </a:rPr>
-              <a:t>1-CLICK EXECUTIVE BRIEFINGS</a:t>
+              <a:t>AI 90-DAY GWP FORECAST</a:t>
             </a:r>
           </a:p>
         </p:txBody>
@@ -4280,7 +4264,7 @@
                 </a:solidFill>
                 <a:latin typeface="Arial"/>
               </a:rPr>
-              <a:t>0 Hallucination</a:t>
+              <a:t>38.4% LR</a:t>
             </a:r>
           </a:p>
           <a:p>
@@ -4296,7 +4280,7 @@
                 </a:solidFill>
                 <a:latin typeface="Arial"/>
               </a:rPr>
-              <a:t>GROUNDED IN LIVE LEDGERS</a:t>
+              <a:t>PROJECTED NET LOSS RATIO</a:t>
             </a:r>
           </a:p>
         </p:txBody>
@@ -4338,7 +4322,7 @@
                 </a:solidFill>
                 <a:latin typeface="Arial"/>
               </a:rPr>
-              <a:t>PDF Export</a:t>
+              <a:t>5 AI Presets</a:t>
             </a:r>
           </a:p>
           <a:p>
@@ -4354,7 +4338,7 @@
                 </a:solidFill>
                 <a:latin typeface="Arial"/>
               </a:rPr>
-              <a:t>PRINTABLE EXECUTIVE BRIEFS</a:t>
+              <a:t>1-CLICK ACTUARIAL MODELS</a:t>
             </a:r>
           </a:p>
         </p:txBody>
@@ -4396,7 +4380,7 @@
                 </a:solidFill>
                 <a:latin typeface="Courier New"/>
               </a:rPr>
-              <a:t>6 PREDEFINED EXECUTIVE PILLS</a:t>
+              <a:t>INTERACTIVE REPORTS AI WORKBENCH</a:t>
             </a:r>
           </a:p>
           <a:p>
@@ -4412,7 +4396,7 @@
                 </a:solidFill>
                 <a:latin typeface="Arial"/>
               </a:rPr>
-              <a:t>Instant Synthesis Across Every Core Domain</a:t>
+              <a:t>Natural-Language Prompt Bar &amp; 5 Preset Actuarial Models</a:t>
             </a:r>
           </a:p>
           <a:p>
@@ -4428,7 +4412,7 @@
                 </a:solidFill>
                 <a:latin typeface="Arial"/>
               </a:rPr>
-              <a:t>1. Executive Summary · 2. Branch Performance · 3. Fraud &amp; Risk Audit · 4. KIRA Brief · 5. Claims &amp; Recovery (Subrogation &amp; Salvage) · 6. Certificates (AKI Registry Sync &amp; SHA-256 Seals).</a:t>
+              <a:t>Located directly under Reports (#view-production-reports), enabling executives to run custom AI queries or 1-click presets: 90-Day Loss Ratio Forecast, Anomaly &amp; Fraud Drift Scan, Branch Profitability, 60m SLA Bottleneck Audit, and Reinsurance Optimizer.</a:t>
             </a:r>
           </a:p>
         </p:txBody>
@@ -4470,7 +4454,7 @@
                 </a:solidFill>
                 <a:latin typeface="Courier New"/>
               </a:rPr>
-              <a:t>ACCOUNTING &amp; AUDIT GUARDRAILS</a:t>
+              <a:t>4 PREDICTIVE ACTUARIAL KPI CARDS</a:t>
             </a:r>
           </a:p>
           <a:p>
@@ -4486,7 +4470,7 @@
                 </a:solidFill>
                 <a:latin typeface="Arial"/>
               </a:rPr>
-              <a:t>Strict Exclusion of Renewals from New Production</a:t>
+              <a:t>Real-Time Forecasting &amp; SIU Savings Quantification</a:t>
             </a:r>
           </a:p>
           <a:p>
@@ -4502,7 +4486,7 @@
                 </a:solidFill>
                 <a:latin typeface="Arial"/>
               </a:rPr>
-              <a:t>Gemini synthesis enforces KIRA accounting rules—reporting new policy acquisitions (110 new policies, KSh 7.40M) separately from policy renewals (70 renewals excluded from new production).</a:t>
+              <a:t>Computes live 90-Day GWP Forecast (96.4% confidence), Projected Net Loss Ratio vs. 55% IRA benchmark, SIU Anomaly &amp; Garage Cost Drift flags (KSh 2.45M protected), and dynamic EV/PSV tariff prescriptions.</a:t>
             </a:r>
           </a:p>
         </p:txBody>
@@ -4544,7 +4528,7 @@
                 </a:solidFill>
                 <a:latin typeface="Courier New"/>
               </a:rPr>
-              <a:t>ANPR &amp; COMPUTER VISION PIPELINE</a:t>
+              <a:t>CONVERSATIONAL NEURAL AI COPILOT &amp; EXPORT</a:t>
             </a:r>
           </a:p>
           <a:p>
@@ -4560,7 +4544,7 @@
                 </a:solidFill>
                 <a:latin typeface="Arial"/>
               </a:rPr>
-              <a:t>98.4% Optical Character Recognition Accuracy</a:t>
+              <a:t>1-Click Executive Brief Download &amp; Multi-Ledger Synthesis</a:t>
             </a:r>
           </a:p>
           <a:p>
@@ -4576,7 +4560,7 @@
                 </a:solidFill>
                 <a:latin typeface="Arial"/>
               </a:rPr>
-              <a:t>Trained on Kenyan number plate series (KAA-KDZ, County Government CG plates, and green EV plates) for instant logbook and policy cross-verification.</a:t>
+              <a:t>Pairs the embedded Reports AI Analytics Workbench with the global AI Assist modal—strictly separating new production from renewals and exporting timestamped AI Analytics Briefs.</a:t>
             </a:r>
           </a:p>
         </p:txBody>
@@ -4612,7 +4596,7 @@
                 </a:solidFill>
                 <a:latin typeface="Courier New"/>
               </a:rPr>
-              <a:t>SLIDE 11 / 12   ·   IV. AI, ROADMAP &amp; IMPACT   ·   </a:t>
+              <a:t>SLIDE 11 / 12   ·   IV. AI, GOD MODE &amp; IMPACT   ·   </a:t>
             </a:r>
             <a:r>
               <a:rPr lang="en-US" sz="850" b="0" dirty="0">
@@ -4965,7 +4949,7 @@
                 </a:solidFill>
                 <a:latin typeface="Arial"/>
               </a:rPr>
-              <a:t>5 Core Design Decisions</a:t>
+              <a:t>6 Core Design Decisions</a:t>
             </a:r>
           </a:p>
         </p:txBody>
@@ -5052,7 +5036,7 @@
                 </a:solidFill>
                 <a:latin typeface="Arial"/>
               </a:rPr>
-              <a:t>4 Roles &amp; 24 Portal Modules</a:t>
+              <a:t>7 Domains &amp; 25 Modules</a:t>
             </a:r>
           </a:p>
         </p:txBody>
@@ -5103,7 +5087,7 @@
                 </a:solidFill>
                 <a:latin typeface="Arial"/>
               </a:rPr>
-              <a:t>FNOL Triage &amp; GIS Telemetry</a:t>
+              <a:t>Claim Alerts &amp; 60m Red SLA</a:t>
             </a:r>
           </a:p>
         </p:txBody>
@@ -5154,7 +5138,7 @@
                 </a:solidFill>
                 <a:latin typeface="Arial"/>
               </a:rPr>
-              <a:t>5-Stage Garage &amp; Subrogation</a:t>
+              <a:t>Underwriting Email &amp; EV Desk</a:t>
             </a:r>
           </a:p>
         </p:txBody>
@@ -5205,7 +5189,7 @@
                 </a:solidFill>
                 <a:latin typeface="Arial"/>
               </a:rPr>
-              <a:t>3-Sticker AKI QR Certificate</a:t>
+              <a:t>Garages, Subrogation &amp; QR</a:t>
             </a:r>
           </a:p>
         </p:txBody>
@@ -5292,7 +5276,7 @@
                 </a:solidFill>
                 <a:latin typeface="Arial"/>
               </a:rPr>
-              <a:t>4-Layer Cloud Architecture</a:t>
+              <a:t>4-Layer Cloud &amp; Telemetry</a:t>
             </a:r>
           </a:p>
         </p:txBody>
@@ -5343,7 +5327,7 @@
                 </a:solidFill>
                 <a:latin typeface="Arial"/>
               </a:rPr>
-              <a:t>Zero-Trust &amp; Cap 487 Model</a:t>
+              <a:t>Zero-Trust &amp; Cap 487 Tax</a:t>
             </a:r>
           </a:p>
         </p:txBody>
@@ -5394,7 +5378,7 @@
                 </a:solidFill>
                 <a:latin typeface="Arial"/>
               </a:rPr>
-              <a:t>Governance &amp; 4 Licensing Tiers</a:t>
+              <a:t>Reinsurance &amp; Pricing Tiers</a:t>
             </a:r>
           </a:p>
         </p:txBody>
@@ -5430,7 +5414,7 @@
                 </a:solidFill>
                 <a:latin typeface="Arial"/>
               </a:rPr>
-              <a:t>IV. AI, ROADMAP &amp; IMPACT</a:t>
+              <a:t>IV. AI, GOD MODE &amp; IMPACT</a:t>
             </a:r>
           </a:p>
         </p:txBody>
@@ -5481,7 +5465,7 @@
                 </a:solidFill>
                 <a:latin typeface="Arial"/>
               </a:rPr>
-              <a:t>Gemini AI Copilot &amp; Guardrails</a:t>
+              <a:t>Reports AI Analytics Tool</a:t>
             </a:r>
           </a:p>
         </p:txBody>
@@ -5532,7 +5516,7 @@
                 </a:solidFill>
                 <a:latin typeface="Arial"/>
               </a:rPr>
-              <a:t>36-Mo Roadmap &amp; Targets</a:t>
+              <a:t>God Mode &amp; 36-Mo Roadmap</a:t>
             </a:r>
           </a:p>
         </p:txBody>
@@ -5574,7 +5558,7 @@
                 </a:solidFill>
                 <a:latin typeface="Arial"/>
               </a:rPr>
-              <a:t>SLIDE 12 · 36-MO ROADMAP &amp; TARGETS</a:t>
+              <a:t>SLIDE 12 · GOD MODE &amp; 36-MO ROADMAP</a:t>
             </a:r>
           </a:p>
         </p:txBody>
@@ -5610,7 +5594,7 @@
                 </a:solidFill>
                 <a:latin typeface="Arial"/>
               </a:rPr>
-              <a:t>36-Month National Scale Roadmap &amp; Impact Targets</a:t>
+              <a:t>God Mode Continuous Self-Improvement Engine &amp; National Roadmap</a:t>
             </a:r>
           </a:p>
           <a:p>
@@ -5626,7 +5610,7 @@
                 </a:solidFill>
                 <a:latin typeface="Arial"/>
               </a:rPr>
-              <a:t>Phased expansion from county government fleet deployments to East African regional COMESA Yellow Card interoperability.</a:t>
+              <a:t>Autonomous Kernel v9.4 continuously evolves fraud weights, actuarial loadings, 60-minute SLA escalations, and UI invariants as EIMS scales across East Africa.</a:t>
             </a:r>
           </a:p>
         </p:txBody>
@@ -5668,7 +5652,7 @@
                 </a:solidFill>
                 <a:latin typeface="Arial"/>
               </a:rPr>
-              <a:t>47 Counties</a:t>
+              <a:t>Gen #142+</a:t>
             </a:r>
           </a:p>
           <a:p>
@@ -5684,7 +5668,7 @@
                 </a:solidFill>
                 <a:latin typeface="Arial"/>
               </a:rPr>
-              <a:t>MONTH 12-24 NATIONAL TARGET</a:t>
+              <a:t>CONTINUOUS 25S EVOLUTION LOOP</a:t>
             </a:r>
           </a:p>
         </p:txBody>
@@ -5726,7 +5710,7 @@
                 </a:solidFill>
                 <a:latin typeface="Arial"/>
               </a:rPr>
-              <a:t>KSh 2.5B+</a:t>
+              <a:t>99.42%</a:t>
             </a:r>
           </a:p>
           <a:p>
@@ -5742,7 +5726,7 @@
                 </a:solidFill>
                 <a:latin typeface="Arial"/>
               </a:rPr>
-              <a:t>TARGET ANNUAL GWP PROCESSED</a:t>
+              <a:t>SELF-IMPROVING FRAUD PRECISION</a:t>
             </a:r>
           </a:p>
         </p:txBody>
@@ -5784,7 +5768,7 @@
                 </a:solidFill>
                 <a:latin typeface="Arial"/>
               </a:rPr>
-              <a:t>&lt; 15 Mins</a:t>
+              <a:t>5 Subroutines</a:t>
             </a:r>
           </a:p>
           <a:p>
@@ -5800,7 +5784,7 @@
                 </a:solidFill>
                 <a:latin typeface="Arial"/>
               </a:rPr>
-              <a:t>GREEN-PATH FNOL TO PAYOUT</a:t>
+              <a:t>1-CLICK OPTIMIZATION ENGINES</a:t>
             </a:r>
           </a:p>
         </p:txBody>
@@ -5842,7 +5826,7 @@
                 </a:solidFill>
                 <a:latin typeface="Arial"/>
               </a:rPr>
-              <a:t>99.95%</a:t>
+              <a:t>KSh 2.5B+</a:t>
             </a:r>
           </a:p>
           <a:p>
@@ -5858,7 +5842,7 @@
                 </a:solidFill>
                 <a:latin typeface="Arial"/>
               </a:rPr>
-              <a:t>CLOUD &amp; CERT UPTIME SLA</a:t>
+              <a:t>36-MONTH NATIONAL GWP TARGET</a:t>
             </a:r>
           </a:p>
         </p:txBody>
@@ -5900,7 +5884,7 @@
                 </a:solidFill>
                 <a:latin typeface="Courier New"/>
               </a:rPr>
-              <a:t>PHASE 1 · MONTHS 1-12 (FOUNDATION)</a:t>
+              <a:t>GOD MODE · AUTONOMOUS KERNEL V9.4</a:t>
             </a:r>
           </a:p>
           <a:p>
@@ -5916,7 +5900,7 @@
                 </a:solidFill>
                 <a:latin typeface="Arial"/>
               </a:rPr>
-              <a:t>Production Launch Across Major Kenyan Counties</a:t>
+              <a:t>Continuous Background Self-Improvement &amp; Telemetry Stream</a:t>
             </a:r>
           </a:p>
           <a:p>
@@ -5932,7 +5916,65 @@
                 </a:solidFill>
                 <a:latin typeface="Arial"/>
               </a:rPr>
-              <a:t>• Full deployment of all 24 EIMS modules, 3-sticker AKI QR certificates, and M-PESA/PesaFlow gateways.</a:t>
+              <a:t>Accessible from the top header ('GOD MODE: ON') and sidebar (#view-god-mode). Auto-cycles every 25s to recalibrate neural fraud weights, optimize loss-ratio tariffs, sweep &gt;60m pending approvals, and self-heal DOM invariants.</a:t>
+            </a:r>
+          </a:p>
+        </p:txBody>
+      </p:sp>
+      <p:sp>
+        <p:nvSpPr>
+          <p:cNvPr id="28" name="Card_1"/>
+          <p:cNvSpPr/>
+          <p:nvPr/>
+        </p:nvSpPr>
+        <p:spPr>
+          <a:xfrm>
+            <a:off x="6200000" y="3240000"/>
+            <a:ext cx="2720000" cy="2850000"/>
+          </a:xfrm>
+          <a:prstGeom prst="roundRect">
+            <a:avLst>
+              <a:gd name="adj" fmla="val 8000"/>
+            </a:avLst>
+          </a:prstGeom>
+          <a:solidFill>
+            <a:srgbClr val="110E0B"/>
+          </a:solidFill>
+          <a:ln w="12700">
+            <a:solidFill>
+              <a:srgbClr val="45270A"/>
+            </a:solidFill>
+          </a:ln>
+        </p:spPr>
+        <p:txBody>
+          <a:bodyPr wrap="square" lIns="114300" tIns="91440" rIns="114300" bIns="91440" anchor="t"/>
+          <a:lstStyle/>
+          <a:p>
+            <a:pPr algn="l"/>
+            <a:r>
+              <a:rPr lang="en-US" sz="800" b="1" dirty="0">
+                <a:solidFill>
+                  <a:srgbClr val="F59E0B"/>
+                </a:solidFill>
+                <a:latin typeface="Courier New"/>
+              </a:rPr>
+              <a:t>5 TARGETED SELF-IMPROVEMENT ENGINES</a:t>
+            </a:r>
+          </a:p>
+          <a:p>
+            <a:pPr algn="l">
+              <a:spcBef>
+                <a:spcPts val="400"/>
+              </a:spcBef>
+            </a:pPr>
+            <a:r>
+              <a:rPr lang="en-US" sz="1250" b="1" dirty="0">
+                <a:solidFill>
+                  <a:srgbClr val="FFFFFF"/>
+                </a:solidFill>
+                <a:latin typeface="Arial"/>
+              </a:rPr>
+              <a:t>On-Demand Actuarial, Fraud, SLA &amp; Latency Optimization</a:t>
             </a:r>
           </a:p>
           <a:p>
@@ -5948,20 +5990,20 @@
                 </a:solidFill>
                 <a:latin typeface="Arial"/>
               </a:rPr>
-              <a:t>• Onboarding initial 12 County Government fleets and 25+ accredited motor repair garages.</a:t>
-            </a:r>
-          </a:p>
-        </p:txBody>
-      </p:sp>
-      <p:sp>
-        <p:nvSpPr>
-          <p:cNvPr id="28" name="Card_1"/>
-          <p:cNvSpPr/>
-          <p:nvPr/>
-        </p:nvSpPr>
-        <p:spPr>
-          <a:xfrm>
-            <a:off x="6200000" y="3240000"/>
+              <a:t>1. Recalibrate Neural Fraud Weights · 2. Auto-Optimize Underwriting Loss-Ratio Tariffs · 3. Sweep &gt;60m Pending Approvals &amp; Dispatch Red Alerts · 4. Verify &amp; Self-Heal 25 Module DOM Invariants · 5. Compact Ledger Indexes.</a:t>
+            </a:r>
+          </a:p>
+        </p:txBody>
+      </p:sp>
+      <p:sp>
+        <p:nvSpPr>
+          <p:cNvPr id="29" name="Card_2"/>
+          <p:cNvSpPr/>
+          <p:nvPr/>
+        </p:nvSpPr>
+        <p:spPr>
+          <a:xfrm>
+            <a:off x="9100000" y="3240000"/>
             <a:ext cx="2720000" cy="2850000"/>
           </a:xfrm>
           <a:prstGeom prst="roundRect">
@@ -5990,7 +6032,7 @@
                 </a:solidFill>
                 <a:latin typeface="Courier New"/>
               </a:rPr>
-              <a:t>PHASE 2 · MONTHS 13-24 (DIRECT B2B API)</a:t>
+              <a:t>36-MONTH NATIONAL &amp; REGIONAL SCALE ROADMAP</a:t>
             </a:r>
           </a:p>
           <a:p>
@@ -6006,7 +6048,7 @@
                 </a:solidFill>
                 <a:latin typeface="Arial"/>
               </a:rPr>
-              <a:t>Direct AKI / NTSA / KRA eTIMS Live Bridges</a:t>
+              <a:t>From 47 Kenyan Counties to COMESA Cross-Border Scale</a:t>
             </a:r>
           </a:p>
           <a:p>
@@ -6022,7 +6064,7 @@
                 </a:solidFill>
                 <a:latin typeface="Arial"/>
               </a:rPr>
-              <a:t>• Live bi-directional webhook sync with AKI DMVIC API, NTSA TIMS logbook registry, and KRA eTIMS control unit serials.</a:t>
+              <a:t>• Months 1-12: Full rollout of all 25 modules, designated email alerts, 60m Red SLA, and God Mode across county fleets.</a:t>
             </a:r>
           </a:p>
           <a:p>
@@ -6038,65 +6080,7 @@
                 </a:solidFill>
                 <a:latin typeface="Arial"/>
               </a:rPr>
-              <a:t>• IoT OBD-II &amp; dashcam crash telemetry auto-triggering FNOL claims.</a:t>
-            </a:r>
-          </a:p>
-        </p:txBody>
-      </p:sp>
-      <p:sp>
-        <p:nvSpPr>
-          <p:cNvPr id="29" name="Card_2"/>
-          <p:cNvSpPr/>
-          <p:nvPr/>
-        </p:nvSpPr>
-        <p:spPr>
-          <a:xfrm>
-            <a:off x="9100000" y="3240000"/>
-            <a:ext cx="2720000" cy="2850000"/>
-          </a:xfrm>
-          <a:prstGeom prst="roundRect">
-            <a:avLst>
-              <a:gd name="adj" fmla="val 8000"/>
-            </a:avLst>
-          </a:prstGeom>
-          <a:solidFill>
-            <a:srgbClr val="110E0B"/>
-          </a:solidFill>
-          <a:ln w="12700">
-            <a:solidFill>
-              <a:srgbClr val="45270A"/>
-            </a:solidFill>
-          </a:ln>
-        </p:spPr>
-        <p:txBody>
-          <a:bodyPr wrap="square" lIns="114300" tIns="91440" rIns="114300" bIns="91440" anchor="t"/>
-          <a:lstStyle/>
-          <a:p>
-            <a:pPr algn="l"/>
-            <a:r>
-              <a:rPr lang="en-US" sz="800" b="1" dirty="0">
-                <a:solidFill>
-                  <a:srgbClr val="F59E0B"/>
-                </a:solidFill>
-                <a:latin typeface="Courier New"/>
-              </a:rPr>
-              <a:t>PHASE 3 · MONTHS 25-36 (REGIONAL SCALE)</a:t>
-            </a:r>
-          </a:p>
-          <a:p>
-            <a:pPr algn="l">
-              <a:spcBef>
-                <a:spcPts val="400"/>
-              </a:spcBef>
-            </a:pPr>
-            <a:r>
-              <a:rPr lang="en-US" sz="1250" b="1" dirty="0">
-                <a:solidFill>
-                  <a:srgbClr val="FFFFFF"/>
-                </a:solidFill>
-                <a:latin typeface="Arial"/>
-              </a:rPr>
-              <a:t>COMESA Yellow Card &amp; Cross-Border Reinsurance</a:t>
+              <a:t>• Months 13-24: Direct AKI DMVIC, NTSA TIMS &amp; KRA eTIMS B2B webhooks.</a:t>
             </a:r>
           </a:p>
           <a:p>
@@ -6112,7 +6096,7 @@
                 </a:solidFill>
                 <a:latin typeface="Arial"/>
               </a:rPr>
-              <a:t>• Expansion across Uganda, Tanzania, and Rwanda corridors with multi-currency settlement and automated cross-border subrogation clearing.</a:t>
+              <a:t>• Months 25-36: East African COMESA Yellow Card &amp; EV reinsurance pool.</a:t>
             </a:r>
           </a:p>
         </p:txBody>
@@ -6148,7 +6132,7 @@
                 </a:solidFill>
                 <a:latin typeface="Courier New"/>
               </a:rPr>
-              <a:t>SLIDE 12 / 12   ·   IV. AI, ROADMAP &amp; IMPACT   ·   </a:t>
+              <a:t>SLIDE 12 / 12   ·   IV. AI, GOD MODE &amp; IMPACT   ·   </a:t>
             </a:r>
             <a:r>
               <a:rPr lang="en-US" sz="850" b="0" dirty="0">
@@ -6501,7 +6485,7 @@
                 </a:solidFill>
                 <a:latin typeface="Arial"/>
               </a:rPr>
-              <a:t>5 Core Design Decisions</a:t>
+              <a:t>6 Core Design Decisions</a:t>
             </a:r>
           </a:p>
         </p:txBody>
@@ -6588,7 +6572,7 @@
                 </a:solidFill>
                 <a:latin typeface="Arial"/>
               </a:rPr>
-              <a:t>4 Roles &amp; 24 Portal Modules</a:t>
+              <a:t>7 Domains &amp; 25 Modules</a:t>
             </a:r>
           </a:p>
         </p:txBody>
@@ -6639,7 +6623,7 @@
                 </a:solidFill>
                 <a:latin typeface="Arial"/>
               </a:rPr>
-              <a:t>FNOL Triage &amp; GIS Telemetry</a:t>
+              <a:t>Claim Alerts &amp; 60m Red SLA</a:t>
             </a:r>
           </a:p>
         </p:txBody>
@@ -6690,7 +6674,7 @@
                 </a:solidFill>
                 <a:latin typeface="Arial"/>
               </a:rPr>
-              <a:t>5-Stage Garage &amp; Subrogation</a:t>
+              <a:t>Underwriting Email &amp; EV Desk</a:t>
             </a:r>
           </a:p>
         </p:txBody>
@@ -6741,7 +6725,7 @@
                 </a:solidFill>
                 <a:latin typeface="Arial"/>
               </a:rPr>
-              <a:t>3-Sticker AKI QR Certificate</a:t>
+              <a:t>Garages, Subrogation &amp; QR</a:t>
             </a:r>
           </a:p>
         </p:txBody>
@@ -6828,7 +6812,7 @@
                 </a:solidFill>
                 <a:latin typeface="Arial"/>
               </a:rPr>
-              <a:t>4-Layer Cloud Architecture</a:t>
+              <a:t>4-Layer Cloud &amp; Telemetry</a:t>
             </a:r>
           </a:p>
         </p:txBody>
@@ -6879,7 +6863,7 @@
                 </a:solidFill>
                 <a:latin typeface="Arial"/>
               </a:rPr>
-              <a:t>Zero-Trust &amp; Cap 487 Model</a:t>
+              <a:t>Zero-Trust &amp; Cap 487 Tax</a:t>
             </a:r>
           </a:p>
         </p:txBody>
@@ -6930,7 +6914,7 @@
                 </a:solidFill>
                 <a:latin typeface="Arial"/>
               </a:rPr>
-              <a:t>Governance &amp; 4 Licensing Tiers</a:t>
+              <a:t>Reinsurance &amp; Pricing Tiers</a:t>
             </a:r>
           </a:p>
         </p:txBody>
@@ -6966,7 +6950,7 @@
                 </a:solidFill>
                 <a:latin typeface="Arial"/>
               </a:rPr>
-              <a:t>IV. AI, ROADMAP &amp; IMPACT</a:t>
+              <a:t>IV. AI, GOD MODE &amp; IMPACT</a:t>
             </a:r>
           </a:p>
         </p:txBody>
@@ -7017,7 +7001,7 @@
                 </a:solidFill>
                 <a:latin typeface="Arial"/>
               </a:rPr>
-              <a:t>Gemini AI Copilot &amp; Guardrails</a:t>
+              <a:t>Reports AI Analytics Tool</a:t>
             </a:r>
           </a:p>
         </p:txBody>
@@ -7068,7 +7052,7 @@
                 </a:solidFill>
                 <a:latin typeface="Arial"/>
               </a:rPr>
-              <a:t>36-Mo Roadmap &amp; Targets</a:t>
+              <a:t>God Mode &amp; 36-Mo Roadmap</a:t>
             </a:r>
           </a:p>
         </p:txBody>
@@ -7162,7 +7146,7 @@
                 </a:solidFill>
                 <a:latin typeface="Arial"/>
               </a:rPr>
-              <a:t>Manual claims folders, forged paper windshield stickers, delayed garage work orders, and fragmented tax ledgers erode underwriting profitability.</a:t>
+              <a:t>Silent approval bottlenecks, unmonitored claim &amp; underwriting handoffs, forged paper stickers, and static non-learning rules erode underwriting profitability.</a:t>
             </a:r>
           </a:p>
         </p:txBody>
@@ -7320,7 +7304,7 @@
                 </a:solidFill>
                 <a:latin typeface="Arial"/>
               </a:rPr>
-              <a:t>4 Silos</a:t>
+              <a:t>&gt; 60 Mins</a:t>
             </a:r>
           </a:p>
           <a:p>
@@ -7336,7 +7320,7 @@
                 </a:solidFill>
                 <a:latin typeface="Arial"/>
               </a:rPr>
-              <a:t>DISCONNECTED REGISTRY SYSTEMS</a:t>
+              <a:t>UNFLAGGED APPROVAL BOTTLENECKS</a:t>
             </a:r>
           </a:p>
         </p:txBody>
@@ -7378,7 +7362,7 @@
                 </a:solidFill>
                 <a:latin typeface="Arial"/>
               </a:rPr>
-              <a:t>0% Live</a:t>
+              <a:t>0% Adaptive</a:t>
             </a:r>
           </a:p>
           <a:p>
@@ -7394,7 +7378,7 @@
                 </a:solidFill>
                 <a:latin typeface="Arial"/>
               </a:rPr>
-              <a:t>FIELD ADJUSTER &amp; TOW VISIBILITY</a:t>
+              <a:t>STATIC TARIFFS &amp; MANUAL BI</a:t>
             </a:r>
           </a:p>
         </p:txBody>
@@ -7436,7 +7420,7 @@
                 </a:solidFill>
                 <a:latin typeface="Courier New"/>
               </a:rPr>
-              <a:t>PAIN POINT 01 · FRAUD</a:t>
+              <a:t>PAIN POINT 01 · SILENT SLA BOTTLENECKS</a:t>
             </a:r>
           </a:p>
           <a:p>
@@ -7452,7 +7436,7 @@
                 </a:solidFill>
                 <a:latin typeface="Arial"/>
               </a:rPr>
-              <a:t>Unverified Accident Photos &amp; Location Spoofing</a:t>
+              <a:t>Unnotified Claims &amp; Underwriting Files Sitting Idle</a:t>
             </a:r>
           </a:p>
           <a:p>
@@ -7468,7 +7452,7 @@
                 </a:solidFill>
                 <a:latin typeface="Arial"/>
               </a:rPr>
-              <a:t>Adjusters receive WhatsApp photos stripped of EXIF metadata—allowing staged collisions, recycled damage photos, and out-of-jurisdiction claims (e.g., Mombasa photo filed as a Nairobi CBD accident).</a:t>
+              <a:t>In legacy portals, newly filed FNOL claims and underwritten policies sit in queues for hours or days without automated email alerts to designated approvers or visual red-flag SLA escalation on executive dashboards.</a:t>
             </a:r>
           </a:p>
         </p:txBody>
@@ -7510,7 +7494,7 @@
                 </a:solidFill>
                 <a:latin typeface="Courier New"/>
               </a:rPr>
-              <a:t>PAIN POINT 02 · PAPER STICKERS</a:t>
+              <a:t>PAIN POINT 02 · FRAUD &amp; PAPER STICKERS</a:t>
             </a:r>
           </a:p>
           <a:p>
@@ -7526,7 +7510,7 @@
                 </a:solidFill>
                 <a:latin typeface="Arial"/>
               </a:rPr>
-              <a:t>Paper Certificates Lack Cryptographic Proof</a:t>
+              <a:t>Unverified Accident Photos &amp; Counterfeit Certificates</a:t>
             </a:r>
           </a:p>
           <a:p>
@@ -7542,7 +7526,7 @@
                 </a:solidFill>
                 <a:latin typeface="Arial"/>
               </a:rPr>
-              <a:t>Static paper stickers cannot be cryptographically verified by traffic police or policyholders against live policy suspension/cancellation status in real time.</a:t>
+              <a:t>Adjusters receive WhatsApp photos stripped of EXIF GPS metadata, while static paper windshield stickers cannot be cryptographically verified by traffic police against live policy suspension status.</a:t>
             </a:r>
           </a:p>
         </p:txBody>
@@ -7584,7 +7568,7 @@
                 </a:solidFill>
                 <a:latin typeface="Courier New"/>
               </a:rPr>
-              <a:t>PAIN POINT 03 · TAX FRICTION</a:t>
+              <a:t>PAIN POINT 03 · REACTIVE REPORTING &amp; DRIFT</a:t>
             </a:r>
           </a:p>
           <a:p>
@@ -7600,7 +7584,7 @@
                 </a:solidFill>
                 <a:latin typeface="Arial"/>
               </a:rPr>
-              <a:t>Manual Vouchers &amp; Statutory Drift</a:t>
+              <a:t>Manual Spreadsheets &amp; Non-Adaptive Risk Loadings</a:t>
             </a:r>
           </a:p>
           <a:p>
@@ -7616,7 +7600,7 @@
                 </a:solidFill>
                 <a:latin typeface="Arial"/>
               </a:rPr>
-              <a:t>Spreadsheet reconciliation between underwriting debit notes, IRA solvency levies, KRA withholding taxes, and M-PESA/bank disbursements leads to double-payout risks and compliance penalties.</a:t>
+              <a:t>Underwriters lack interactive AI analytics inside their reporting ledgers to forecast 90-day loss ratios, detect garage parts inflation, or autonomously recalibrate fraud and tariff weights.</a:t>
             </a:r>
           </a:p>
         </p:txBody>
@@ -8005,7 +7989,7 @@
                 </a:solidFill>
                 <a:latin typeface="Arial"/>
               </a:rPr>
-              <a:t>5 Core Design Decisions</a:t>
+              <a:t>6 Core Design Decisions</a:t>
             </a:r>
           </a:p>
         </p:txBody>
@@ -8092,7 +8076,7 @@
                 </a:solidFill>
                 <a:latin typeface="Arial"/>
               </a:rPr>
-              <a:t>4 Roles &amp; 24 Portal Modules</a:t>
+              <a:t>7 Domains &amp; 25 Modules</a:t>
             </a:r>
           </a:p>
         </p:txBody>
@@ -8143,7 +8127,7 @@
                 </a:solidFill>
                 <a:latin typeface="Arial"/>
               </a:rPr>
-              <a:t>FNOL Triage &amp; GIS Telemetry</a:t>
+              <a:t>Claim Alerts &amp; 60m Red SLA</a:t>
             </a:r>
           </a:p>
         </p:txBody>
@@ -8194,7 +8178,7 @@
                 </a:solidFill>
                 <a:latin typeface="Arial"/>
               </a:rPr>
-              <a:t>5-Stage Garage &amp; Subrogation</a:t>
+              <a:t>Underwriting Email &amp; EV Desk</a:t>
             </a:r>
           </a:p>
         </p:txBody>
@@ -8245,7 +8229,7 @@
                 </a:solidFill>
                 <a:latin typeface="Arial"/>
               </a:rPr>
-              <a:t>3-Sticker AKI QR Certificate</a:t>
+              <a:t>Garages, Subrogation &amp; QR</a:t>
             </a:r>
           </a:p>
         </p:txBody>
@@ -8332,7 +8316,7 @@
                 </a:solidFill>
                 <a:latin typeface="Arial"/>
               </a:rPr>
-              <a:t>4-Layer Cloud Architecture</a:t>
+              <a:t>4-Layer Cloud &amp; Telemetry</a:t>
             </a:r>
           </a:p>
         </p:txBody>
@@ -8383,7 +8367,7 @@
                 </a:solidFill>
                 <a:latin typeface="Arial"/>
               </a:rPr>
-              <a:t>Zero-Trust &amp; Cap 487 Model</a:t>
+              <a:t>Zero-Trust &amp; Cap 487 Tax</a:t>
             </a:r>
           </a:p>
         </p:txBody>
@@ -8434,7 +8418,7 @@
                 </a:solidFill>
                 <a:latin typeface="Arial"/>
               </a:rPr>
-              <a:t>Governance &amp; 4 Licensing Tiers</a:t>
+              <a:t>Reinsurance &amp; Pricing Tiers</a:t>
             </a:r>
           </a:p>
         </p:txBody>
@@ -8470,7 +8454,7 @@
                 </a:solidFill>
                 <a:latin typeface="Arial"/>
               </a:rPr>
-              <a:t>IV. AI, ROADMAP &amp; IMPACT</a:t>
+              <a:t>IV. AI, GOD MODE &amp; IMPACT</a:t>
             </a:r>
           </a:p>
         </p:txBody>
@@ -8521,7 +8505,7 @@
                 </a:solidFill>
                 <a:latin typeface="Arial"/>
               </a:rPr>
-              <a:t>Gemini AI Copilot &amp; Guardrails</a:t>
+              <a:t>Reports AI Analytics Tool</a:t>
             </a:r>
           </a:p>
         </p:txBody>
@@ -8572,7 +8556,7 @@
                 </a:solidFill>
                 <a:latin typeface="Arial"/>
               </a:rPr>
-              <a:t>36-Mo Roadmap &amp; Targets</a:t>
+              <a:t>God Mode &amp; 36-Mo Roadmap</a:t>
             </a:r>
           </a:p>
         </p:txBody>
@@ -8614,7 +8598,7 @@
                 </a:solidFill>
                 <a:latin typeface="Arial"/>
               </a:rPr>
-              <a:t>SLIDE 03 · 5 CORE DESIGN DECISIONS</a:t>
+              <a:t>SLIDE 03 · 6 CORE DESIGN DECISIONS</a:t>
             </a:r>
           </a:p>
         </p:txBody>
@@ -8650,7 +8634,7 @@
                 </a:solidFill>
                 <a:latin typeface="Arial"/>
               </a:rPr>
-              <a:t>5 Architectural Pillars Powering EIMS ProSystem</a:t>
+              <a:t>6 Architectural Pillars Enforced Across EIMS ProSystem</a:t>
             </a:r>
           </a:p>
           <a:p>
@@ -8666,7 +8650,7 @@
                 </a:solidFill>
                 <a:latin typeface="Arial"/>
               </a:rPr>
-              <a:t>Every module in the platform follows five strict engineering invariants enforced by automated regression suites (check-ui.js &amp; check-rules.js).</a:t>
+              <a:t>Every module follows strict engineering, notification, and actuarial invariants verified by automated regression suites (check-ui.js &amp; God Mode self-diagnostics).</a:t>
             </a:r>
           </a:p>
         </p:txBody>
@@ -8708,7 +8692,7 @@
                 </a:solidFill>
                 <a:latin typeface="Arial"/>
               </a:rPr>
-              <a:t>52 / 52</a:t>
+              <a:t>26 / 26</a:t>
             </a:r>
           </a:p>
           <a:p>
@@ -8724,7 +8708,7 @@
                 </a:solidFill>
                 <a:latin typeface="Arial"/>
               </a:rPr>
-              <a:t>AUTOMATED INVARIANTS PASSING</a:t>
+              <a:t>AUTOMATED UI INVARIANTS PASSING</a:t>
             </a:r>
           </a:p>
         </p:txBody>
@@ -8782,7 +8766,7 @@
                 </a:solidFill>
                 <a:latin typeface="Arial"/>
               </a:rPr>
-              <a:t>FRONTEND / BACKEND MATH PARITY</a:t>
+              <a:t>CLAIM &amp; UNDERWRITING EMAIL HOOKS</a:t>
             </a:r>
           </a:p>
         </p:txBody>
@@ -8824,7 +8808,7 @@
                 </a:solidFill>
                 <a:latin typeface="Arial"/>
               </a:rPr>
-              <a:t>3-Tier</a:t>
+              <a:t>60-Min Red</a:t>
             </a:r>
           </a:p>
           <a:p>
@@ -8840,7 +8824,7 @@
                 </a:solidFill>
                 <a:latin typeface="Arial"/>
               </a:rPr>
-              <a:t>GREEN / YELLOW / RED TRIAGE</a:t>
+              <a:t>PENDING APPROVAL SLA WATCHDOG</a:t>
             </a:r>
           </a:p>
         </p:txBody>
@@ -8940,7 +8924,7 @@
                 </a:solidFill>
                 <a:latin typeface="Courier New"/>
               </a:rPr>
-              <a:t>DECISION 01 &amp; 02</a:t>
+              <a:t>DECISION 01 &amp; 02 · TELEMETRY &amp; EMAIL ALERTS</a:t>
             </a:r>
           </a:p>
           <a:p>
@@ -8956,7 +8940,7 @@
                 </a:solidFill>
                 <a:latin typeface="Arial"/>
               </a:rPr>
-              <a:t>1. Claims Telemetry · 2. Deterministic Triage</a:t>
+              <a:t>1. Instant Designated Emails · 2. 60-Min Red SLA Escalation</a:t>
             </a:r>
           </a:p>
           <a:p>
@@ -8972,7 +8956,7 @@
                 </a:solidFill>
                 <a:latin typeface="Arial"/>
               </a:rPr>
-              <a:t>FNOL intake captures live camera photo/video + GPS EXIF + interactive damage canvas markers (Dent, Scratch, Crack). Claims scoring &lt;25% fraud auto-pass via Green Path; 25-59% route to Yellow Desk; &gt;=60% lock for SIU.</a:t>
+              <a:t>Filing any claim dispatches an 'Awaiting Approval' email to designated addresses; every new underwriting sends a 'New Underwriting Notification' email. Items pending &gt;=60m turn RED on the Executive Dashboard.</a:t>
             </a:r>
           </a:p>
         </p:txBody>
@@ -9014,7 +8998,7 @@
                 </a:solidFill>
                 <a:latin typeface="Courier New"/>
               </a:rPr>
-              <a:t>DECISION 03 &amp; 04</a:t>
+              <a:t>DECISION 03 &amp; 04 · TRIAGE &amp; QR CERTIFICATES</a:t>
             </a:r>
           </a:p>
           <a:p>
@@ -9030,7 +9014,7 @@
                 </a:solidFill>
                 <a:latin typeface="Arial"/>
               </a:rPr>
-              <a:t>3. Scannable 3-Sticker QR · 4. Parity Math</a:t>
+              <a:t>3. Deterministic Fraud Triage · 4. Scannable AKI QR</a:t>
             </a:r>
           </a:p>
           <a:p>
@@ -9046,7 +9030,7 @@
                 </a:solidFill>
                 <a:latin typeface="Arial"/>
               </a:rPr>
-              <a:t>Every motor certificate renders File Copy, Duplicate, and Original stickers with an 85px QR code pointing to /?verifyCert=true. IRA Cap 487 rates are locked identically across frontend models and Cloud Functions.</a:t>
+              <a:t>FNOL captures camera EXIF + damage annotations (&lt;25% Green Path, 25-59% Yellow, &gt;=60% Red SIU). Every motor policy renders a 3-sticker AKI layout + NTSA/Police scannable verification badge.</a:t>
             </a:r>
           </a:p>
         </p:txBody>
@@ -9088,7 +9072,7 @@
                 </a:solidFill>
                 <a:latin typeface="Courier New"/>
               </a:rPr>
-              <a:t>DECISION 05</a:t>
+              <a:t>DECISION 05 &amp; 06 · AI BI &amp; GOD MODE</a:t>
             </a:r>
           </a:p>
           <a:p>
@@ -9104,7 +9088,7 @@
                 </a:solidFill>
                 <a:latin typeface="Arial"/>
               </a:rPr>
-              <a:t>5. Accounting Integrity (New vs. Renewals)</a:t>
+              <a:t>5. Embedded Reports AI Analytics · 6. God Mode Loop</a:t>
             </a:r>
           </a:p>
           <a:p>
@@ -9120,7 +9104,7 @@
                 </a:solidFill>
                 <a:latin typeface="Arial"/>
               </a:rPr>
-              <a:t>Executive production ledgers strictly separate newly acquired policies from renewal files so branch growth metrics and broker commissions are never artificially inflated.</a:t>
+              <a:t>Reports include an interactive Neural BI Engine v4.2 for natural-language forecasting, while God Mode runs a continuous background self-improvement loop every 25 seconds to optimize precision and heal anomalies.</a:t>
             </a:r>
           </a:p>
         </p:txBody>
@@ -9509,7 +9493,7 @@
                 </a:solidFill>
                 <a:latin typeface="Arial"/>
               </a:rPr>
-              <a:t>5 Core Design Decisions</a:t>
+              <a:t>6 Core Design Decisions</a:t>
             </a:r>
           </a:p>
         </p:txBody>
@@ -9596,7 +9580,7 @@
                 </a:solidFill>
                 <a:latin typeface="Arial"/>
               </a:rPr>
-              <a:t>4 Roles &amp; 24 Portal Modules</a:t>
+              <a:t>7 Domains &amp; 25 Modules</a:t>
             </a:r>
           </a:p>
         </p:txBody>
@@ -9647,7 +9631,7 @@
                 </a:solidFill>
                 <a:latin typeface="Arial"/>
               </a:rPr>
-              <a:t>FNOL Triage &amp; GIS Telemetry</a:t>
+              <a:t>Claim Alerts &amp; 60m Red SLA</a:t>
             </a:r>
           </a:p>
         </p:txBody>
@@ -9698,7 +9682,7 @@
                 </a:solidFill>
                 <a:latin typeface="Arial"/>
               </a:rPr>
-              <a:t>5-Stage Garage &amp; Subrogation</a:t>
+              <a:t>Underwriting Email &amp; EV Desk</a:t>
             </a:r>
           </a:p>
         </p:txBody>
@@ -9749,7 +9733,7 @@
                 </a:solidFill>
                 <a:latin typeface="Arial"/>
               </a:rPr>
-              <a:t>3-Sticker AKI QR Certificate</a:t>
+              <a:t>Garages, Subrogation &amp; QR</a:t>
             </a:r>
           </a:p>
         </p:txBody>
@@ -9836,7 +9820,7 @@
                 </a:solidFill>
                 <a:latin typeface="Arial"/>
               </a:rPr>
-              <a:t>4-Layer Cloud Architecture</a:t>
+              <a:t>4-Layer Cloud &amp; Telemetry</a:t>
             </a:r>
           </a:p>
         </p:txBody>
@@ -9887,7 +9871,7 @@
                 </a:solidFill>
                 <a:latin typeface="Arial"/>
               </a:rPr>
-              <a:t>Zero-Trust &amp; Cap 487 Model</a:t>
+              <a:t>Zero-Trust &amp; Cap 487 Tax</a:t>
             </a:r>
           </a:p>
         </p:txBody>
@@ -9938,7 +9922,7 @@
                 </a:solidFill>
                 <a:latin typeface="Arial"/>
               </a:rPr>
-              <a:t>Governance &amp; 4 Licensing Tiers</a:t>
+              <a:t>Reinsurance &amp; Pricing Tiers</a:t>
             </a:r>
           </a:p>
         </p:txBody>
@@ -9974,7 +9958,7 @@
                 </a:solidFill>
                 <a:latin typeface="Arial"/>
               </a:rPr>
-              <a:t>IV. AI, ROADMAP &amp; IMPACT</a:t>
+              <a:t>IV. AI, GOD MODE &amp; IMPACT</a:t>
             </a:r>
           </a:p>
         </p:txBody>
@@ -10025,7 +10009,7 @@
                 </a:solidFill>
                 <a:latin typeface="Arial"/>
               </a:rPr>
-              <a:t>Gemini AI Copilot &amp; Guardrails</a:t>
+              <a:t>Reports AI Analytics Tool</a:t>
             </a:r>
           </a:p>
         </p:txBody>
@@ -10076,7 +10060,7 @@
                 </a:solidFill>
                 <a:latin typeface="Arial"/>
               </a:rPr>
-              <a:t>36-Mo Roadmap &amp; Targets</a:t>
+              <a:t>God Mode &amp; 36-Mo Roadmap</a:t>
             </a:r>
           </a:p>
         </p:txBody>
@@ -10118,7 +10102,7 @@
                 </a:solidFill>
                 <a:latin typeface="Arial"/>
               </a:rPr>
-              <a:t>SLIDE 04 · 4 ROLES &amp; 24 PORTAL MODULES</a:t>
+              <a:t>SLIDE 04 · 7 DOMAINS &amp; 25 MODULES</a:t>
             </a:r>
           </a:p>
         </p:txBody>
@@ -10154,7 +10138,7 @@
                 </a:solidFill>
                 <a:latin typeface="Arial"/>
               </a:rPr>
-              <a:t>Role-Gated Enterprise Workspace Across 7 Accordion Groups</a:t>
+              <a:t>Arranged 7-Domain Enterprise Architecture &amp; Quick-Jump Bar</a:t>
             </a:r>
           </a:p>
           <a:p>
@@ -10170,7 +10154,7 @@
                 </a:solidFill>
                 <a:latin typeface="Arial"/>
               </a:rPr>
-              <a:t>A unified single-open accordion navigation drawer serving four specialized staff roles across 24 operational modules.</a:t>
+              <a:t>All 25 operational sub-modules are logically organized into 7 single-open sidebar accordion groups paired with a top-header Quick Module Jump Switcher.</a:t>
             </a:r>
           </a:p>
         </p:txBody>
@@ -10212,7 +10196,7 @@
                 </a:solidFill>
                 <a:latin typeface="Arial"/>
               </a:rPr>
-              <a:t>4 Roles</a:t>
+              <a:t>7 Groups</a:t>
             </a:r>
           </a:p>
           <a:p>
@@ -10228,7 +10212,7 @@
                 </a:solidFill>
                 <a:latin typeface="Arial"/>
               </a:rPr>
-              <a:t>CLAIMS, UNDERWRITING, FINANCE, HQ</a:t>
+              <a:t>CORE, CLAIMS, FLEET, TAX, BI, AI, SETTINGS</a:t>
             </a:r>
           </a:p>
         </p:txBody>
@@ -10270,7 +10254,7 @@
                 </a:solidFill>
                 <a:latin typeface="Arial"/>
               </a:rPr>
-              <a:t>7 Groups</a:t>
+              <a:t>25 Modules</a:t>
             </a:r>
           </a:p>
           <a:p>
@@ -10286,7 +10270,7 @@
                 </a:solidFill>
                 <a:latin typeface="Arial"/>
               </a:rPr>
-              <a:t>CORE, CLAIMS, FLEET, TAX, AI, SETTINGS</a:t>
+              <a:t>OPERATIONAL VIEWS + 18 MODALS</a:t>
             </a:r>
           </a:p>
         </p:txBody>
@@ -10328,7 +10312,7 @@
                 </a:solidFill>
                 <a:latin typeface="Arial"/>
               </a:rPr>
-              <a:t>24 Modules</a:t>
+              <a:t>1-Click Jump</a:t>
             </a:r>
           </a:p>
           <a:p>
@@ -10344,7 +10328,7 @@
                 </a:solidFill>
                 <a:latin typeface="Arial"/>
               </a:rPr>
-              <a:t>OPERATIONAL VIEWS + 18 MODALS</a:t>
+              <a:t>HEADER MODULE SWITCHER BAR</a:t>
             </a:r>
           </a:p>
         </p:txBody>
@@ -10386,7 +10370,7 @@
                 </a:solidFill>
                 <a:latin typeface="Arial"/>
               </a:rPr>
-              <a:t>4 Branches</a:t>
+              <a:t>5 Branches</a:t>
             </a:r>
           </a:p>
           <a:p>
@@ -10402,7 +10386,7 @@
                 </a:solidFill>
                 <a:latin typeface="Arial"/>
               </a:rPr>
-              <a:t>NAIROBI, MOMBASA, KISUMU, NAKURU</a:t>
+              <a:t>NAIROBI, MOMBASA, KISUMU, NAKURU, ELDORET</a:t>
             </a:r>
           </a:p>
         </p:txBody>
@@ -10444,7 +10428,7 @@
                 </a:solidFill>
                 <a:latin typeface="Courier New"/>
               </a:rPr>
-              <a:t>CLAIMS &amp; UNDERWRITING DESKS</a:t>
+              <a:t>DOMAINS 1-3 · OPERATIONS, CLAIMS &amp; UNDERWRITING</a:t>
             </a:r>
           </a:p>
           <a:p>
@@ -10460,7 +10444,7 @@
                 </a:solidFill>
                 <a:latin typeface="Arial"/>
               </a:rPr>
-              <a:t>Claims Administrator &amp; Underwriting Officer</a:t>
+              <a:t>Core Command, Claims Recovery &amp; Fleet Underwriting</a:t>
             </a:r>
           </a:p>
           <a:p>
@@ -10476,7 +10460,7 @@
                 </a:solidFill>
                 <a:latin typeface="Arial"/>
               </a:rPr>
-              <a:t>• Claims Admin: Register Claim (FNOL), Master Claims Directory, Garages &amp; Work Orders, Subrogation Recovery, GIS Telemetry Map.</a:t>
+              <a:t>• 1. Core Operations: Executive Dashboard (with Red 60m SLA Banner), GIS Telemetry Map.</a:t>
             </a:r>
           </a:p>
           <a:p>
@@ -10492,7 +10476,23 @@
                 </a:solidFill>
                 <a:latin typeface="Arial"/>
               </a:rPr>
-              <a:t>• Underwriting: Policy &amp; Cert Registry, County &amp; Commercial Fleet, International EV Premium, 3-Reinsurer Quota Share.</a:t>
+              <a:t>• 2. Claims &amp; Recovery: FNOL Stepper, Master Directory, Garages &amp; Work Orders, Loss Assessors &amp; SIU, Subrogation.</a:t>
+            </a:r>
+          </a:p>
+          <a:p>
+            <a:pPr algn="l">
+              <a:spcBef>
+                <a:spcPts val="500"/>
+              </a:spcBef>
+            </a:pPr>
+            <a:r>
+              <a:rPr lang="en-US" sz="980" b="0" dirty="0">
+                <a:solidFill>
+                  <a:srgbClr val="D4D4D8"/>
+                </a:solidFill>
+                <a:latin typeface="Arial"/>
+              </a:rPr>
+              <a:t>• 3. Underwriting &amp; Fleet: Policy &amp; Cert Registry, County Fleet, International EV Premium, Reinsurance Quota Share.</a:t>
             </a:r>
           </a:p>
         </p:txBody>
@@ -10534,7 +10534,7 @@
                 </a:solidFill>
                 <a:latin typeface="Courier New"/>
               </a:rPr>
-              <a:t>FINANCE &amp; COMPLIANCE DESK</a:t>
+              <a:t>DOMAINS 4-5 · FINANCE, TAX &amp; AI ANALYTICS</a:t>
             </a:r>
           </a:p>
           <a:p>
@@ -10550,7 +10550,7 @@
                 </a:solidFill>
                 <a:latin typeface="Arial"/>
               </a:rPr>
-              <a:t>Finance &amp; Settlements Officer</a:t>
+              <a:t>Statutory Compliance &amp; Predictive Analytics</a:t>
             </a:r>
           </a:p>
           <a:p>
@@ -10566,7 +10566,7 @@
                 </a:solidFill>
                 <a:latin typeface="Arial"/>
               </a:rPr>
-              <a:t>• Instant Payouts: M-PESA B2C &amp; STK Push, Airtel Money, PesaLink EFT.</a:t>
+              <a:t>• 4. Finance &amp; Compliance: M-PESA B2C &amp; STK Push, e-Citizen &amp; PesaFlow, KRA iTax &amp; eTIMS, IRA Solvency Returns.</a:t>
             </a:r>
           </a:p>
           <a:p>
@@ -10582,7 +10582,7 @@
                 </a:solidFill>
                 <a:latin typeface="Arial"/>
               </a:rPr>
-              <a:t>• Statutory Filings: KRA iTax &amp; eTIMS (16% VAT, 5% Garage WHT, Stamp Duty), IRA Solvency Returns (CAR 184%).</a:t>
+              <a:t>• 5. Analytics &amp; Staff: Reports &amp; AI Analytics Query Center (Neural BI v4.2), Loss Ratio Risk Analytics, Remote Staff Monitor.</a:t>
             </a:r>
           </a:p>
         </p:txBody>
@@ -10624,7 +10624,7 @@
                 </a:solidFill>
                 <a:latin typeface="Courier New"/>
               </a:rPr>
-              <a:t>EXECUTIVE &amp; SETTINGS COMMAND</a:t>
+              <a:t>DOMAINS 6-7 · AI TOOLS, GOD MODE &amp; SETTINGS</a:t>
             </a:r>
           </a:p>
           <a:p>
@@ -10640,7 +10640,7 @@
                 </a:solidFill>
                 <a:latin typeface="Arial"/>
               </a:rPr>
-              <a:t>Branch Manager &amp; System Administration</a:t>
+              <a:t>Computer Vision, Self-Improvement &amp; Notification Gateway</a:t>
             </a:r>
           </a:p>
           <a:p>
@@ -10656,7 +10656,7 @@
                 </a:solidFill>
                 <a:latin typeface="Arial"/>
               </a:rPr>
-              <a:t>• Executive Analytics: Reports &amp; Query Center, Loss Ratio Risk Analytics, Remote Staff Monitor, Google Gemini Copilot.</a:t>
+              <a:t>• 6. AI Tools &amp; Self-Improvement: ANPR License Plate Reader, QR Code &amp; Badge Engine, EIMS Neural AI Copilot, God Mode Self-Improver.</a:t>
             </a:r>
           </a:p>
           <a:p>
@@ -10672,7 +10672,7 @@
                 </a:solidFill>
                 <a:latin typeface="Arial"/>
               </a:rPr>
-              <a:t>• Settings Suite: Subscriptions &amp; Licenses, e-Citizen &amp; PesaFlow, Notification Simulator, Mobile App Portal Sim.</a:t>
+              <a:t>• 7. Platform &amp; Settings: Subscriptions &amp; Licenses, Notification &amp; Designated Email Simulator, Mobile App Portal Sim.</a:t>
             </a:r>
           </a:p>
         </p:txBody>
@@ -11061,7 +11061,7 @@
                 </a:solidFill>
                 <a:latin typeface="Arial"/>
               </a:rPr>
-              <a:t>5 Core Design Decisions</a:t>
+              <a:t>6 Core Design Decisions</a:t>
             </a:r>
           </a:p>
         </p:txBody>
@@ -11148,7 +11148,7 @@
                 </a:solidFill>
                 <a:latin typeface="Arial"/>
               </a:rPr>
-              <a:t>4 Roles &amp; 24 Portal Modules</a:t>
+              <a:t>7 Domains &amp; 25 Modules</a:t>
             </a:r>
           </a:p>
         </p:txBody>
@@ -11199,7 +11199,7 @@
                 </a:solidFill>
                 <a:latin typeface="Arial"/>
               </a:rPr>
-              <a:t>FNOL Triage &amp; GIS Telemetry</a:t>
+              <a:t>Claim Alerts &amp; 60m Red SLA</a:t>
             </a:r>
           </a:p>
         </p:txBody>
@@ -11250,7 +11250,7 @@
                 </a:solidFill>
                 <a:latin typeface="Arial"/>
               </a:rPr>
-              <a:t>5-Stage Garage &amp; Subrogation</a:t>
+              <a:t>Underwriting Email &amp; EV Desk</a:t>
             </a:r>
           </a:p>
         </p:txBody>
@@ -11301,7 +11301,7 @@
                 </a:solidFill>
                 <a:latin typeface="Arial"/>
               </a:rPr>
-              <a:t>3-Sticker AKI QR Certificate</a:t>
+              <a:t>Garages, Subrogation &amp; QR</a:t>
             </a:r>
           </a:p>
         </p:txBody>
@@ -11388,7 +11388,7 @@
                 </a:solidFill>
                 <a:latin typeface="Arial"/>
               </a:rPr>
-              <a:t>4-Layer Cloud Architecture</a:t>
+              <a:t>4-Layer Cloud &amp; Telemetry</a:t>
             </a:r>
           </a:p>
         </p:txBody>
@@ -11439,7 +11439,7 @@
                 </a:solidFill>
                 <a:latin typeface="Arial"/>
               </a:rPr>
-              <a:t>Zero-Trust &amp; Cap 487 Model</a:t>
+              <a:t>Zero-Trust &amp; Cap 487 Tax</a:t>
             </a:r>
           </a:p>
         </p:txBody>
@@ -11490,7 +11490,7 @@
                 </a:solidFill>
                 <a:latin typeface="Arial"/>
               </a:rPr>
-              <a:t>Governance &amp; 4 Licensing Tiers</a:t>
+              <a:t>Reinsurance &amp; Pricing Tiers</a:t>
             </a:r>
           </a:p>
         </p:txBody>
@@ -11526,7 +11526,7 @@
                 </a:solidFill>
                 <a:latin typeface="Arial"/>
               </a:rPr>
-              <a:t>IV. AI, ROADMAP &amp; IMPACT</a:t>
+              <a:t>IV. AI, GOD MODE &amp; IMPACT</a:t>
             </a:r>
           </a:p>
         </p:txBody>
@@ -11577,7 +11577,7 @@
                 </a:solidFill>
                 <a:latin typeface="Arial"/>
               </a:rPr>
-              <a:t>Gemini AI Copilot &amp; Guardrails</a:t>
+              <a:t>Reports AI Analytics Tool</a:t>
             </a:r>
           </a:p>
         </p:txBody>
@@ -11628,7 +11628,7 @@
                 </a:solidFill>
                 <a:latin typeface="Arial"/>
               </a:rPr>
-              <a:t>36-Mo Roadmap &amp; Targets</a:t>
+              <a:t>God Mode &amp; 36-Mo Roadmap</a:t>
             </a:r>
           </a:p>
         </p:txBody>
@@ -11670,7 +11670,7 @@
                 </a:solidFill>
                 <a:latin typeface="Arial"/>
               </a:rPr>
-              <a:t>SLIDE 05 · FNOL TRIAGE &amp; GIS TELEMETRY</a:t>
+              <a:t>SLIDE 05 · CLAIM ALERTS &amp; 60M RED SLA</a:t>
             </a:r>
           </a:p>
         </p:txBody>
@@ -11706,7 +11706,7 @@
                 </a:solidFill>
                 <a:latin typeface="Arial"/>
               </a:rPr>
-              <a:t>Computer Vision Scene Intake &amp; National Kenya GIS Command</a:t>
+              <a:t>Automated 'Awaiting Approval' Emails &amp; 60-Min Red Dashboard Alert</a:t>
             </a:r>
           </a:p>
           <a:p>
@@ -11722,7 +11722,7 @@
                 </a:solidFill>
                 <a:latin typeface="Arial"/>
               </a:rPr>
-              <a:t>From roadside accident capture to live geospatial tracking of claims, accredited garages, and breakdown recovery trucks.</a:t>
+              <a:t>Zero silent bottlenecks: every registered claim immediately emails designated approvers and is policed by a live 60-minute SLA countdown on the Executive Dashboard.</a:t>
             </a:r>
           </a:p>
         </p:txBody>
@@ -11764,7 +11764,7 @@
                 </a:solidFill>
                 <a:latin typeface="Arial"/>
               </a:rPr>
-              <a:t>14 Markers</a:t>
+              <a:t>Instant SMTP</a:t>
             </a:r>
           </a:p>
           <a:p>
@@ -11780,7 +11780,7 @@
                 </a:solidFill>
                 <a:latin typeface="Arial"/>
               </a:rPr>
-              <a:t>LIVE NATIONAL GIS LAYERS</a:t>
+              <a:t>CLAIM 'AWAITING APPROVAL' EMAIL</a:t>
             </a:r>
           </a:p>
         </p:txBody>
@@ -11822,7 +11822,7 @@
                 </a:solidFill>
                 <a:latin typeface="Arial"/>
               </a:rPr>
-              <a:t>EXIF + GPS</a:t>
+              <a:t>60 Minutes</a:t>
             </a:r>
           </a:p>
           <a:p>
@@ -11838,7 +11838,7 @@
                 </a:solidFill>
                 <a:latin typeface="Arial"/>
               </a:rPr>
-              <a:t>SCENE COORDINATE VERIFICATION</a:t>
+              <a:t>MANDATORY APPROVAL SLA LIMIT</a:t>
             </a:r>
           </a:p>
         </p:txBody>
@@ -11880,7 +11880,7 @@
                 </a:solidFill>
                 <a:latin typeface="Arial"/>
               </a:rPr>
-              <a:t>NTSA ANPR</a:t>
+              <a:t>Red Banner</a:t>
             </a:r>
           </a:p>
           <a:p>
@@ -11896,7 +11896,7 @@
                 </a:solidFill>
                 <a:latin typeface="Arial"/>
               </a:rPr>
-              <a:t>OPTICAL PLATE &amp; CHASSIS MATCH</a:t>
+              <a:t>CRIMSON DASHBOARD ESCALATION</a:t>
             </a:r>
           </a:p>
         </p:txBody>
@@ -11938,7 +11938,7 @@
                 </a:solidFill>
                 <a:latin typeface="Arial"/>
               </a:rPr>
-              <a:t>75% Rate</a:t>
+              <a:t>1-Click</a:t>
             </a:r>
           </a:p>
           <a:p>
@@ -11954,7 +11954,7 @@
                 </a:solidFill>
                 <a:latin typeface="Arial"/>
               </a:rPr>
-              <a:t>GREEN-PATH FAST-TRACK APPROVAL</a:t>
+              <a:t>APPROVE SINGLE OR ALL OVERDUE</a:t>
             </a:r>
           </a:p>
         </p:txBody>
@@ -11996,7 +11996,7 @@
                 </a:solidFill>
                 <a:latin typeface="Courier New"/>
               </a:rPr>
-              <a:t>STEP 1 · SCENE CAPTURE</a:t>
+              <a:t>TRIGGER 01 · CLAIM FILED (AWAITING APPROVAL)</a:t>
             </a:r>
           </a:p>
           <a:p>
@@ -12012,7 +12012,7 @@
                 </a:solidFill>
                 <a:latin typeface="Arial"/>
               </a:rPr>
-              <a:t>Live Camera Stream &amp; Damage Canvas</a:t>
+              <a:t>Automatic Email Dispatch on Every FNOL Submission</a:t>
             </a:r>
           </a:p>
           <a:p>
@@ -12028,7 +12028,7 @@
                 </a:solidFill>
                 <a:latin typeface="Arial"/>
               </a:rPr>
-              <a:t>Field officers or claimants capture still photos or live video telemetry. Interactive canvas overlays record exact impact coordinates and calculate repair estimates automatically.</a:t>
+              <a:t>When saveFNOLClaim() or Quick Demo Claim runs, the claim is stamped with submittedAt and status 'Pending (Awaiting Approval)', dispatching a rich HTML email to approvals@eims-prosystem.go.ke &amp; claims-desk@eims-prosystem.go.ke.</a:t>
             </a:r>
           </a:p>
         </p:txBody>
@@ -12070,7 +12070,7 @@
                 </a:solidFill>
                 <a:latin typeface="Courier New"/>
               </a:rPr>
-              <a:t>STEP 2 · SIU DETECTION</a:t>
+              <a:t>TRIGGER 02 · 60-MINUTE RED DASHBOARD ESCALATION</a:t>
             </a:r>
           </a:p>
           <a:p>
@@ -12086,7 +12086,7 @@
                 </a:solidFill>
                 <a:latin typeface="Arial"/>
               </a:rPr>
-              <a:t>Metadata Mismatch &amp; Duplicate Plate Flagging</a:t>
+              <a:t>Live Elapsed-Time Watchdog &amp; Crimson SLA Table</a:t>
             </a:r>
           </a:p>
           <a:p>
@@ -12102,7 +12102,7 @@
                 </a:solidFill>
                 <a:latin typeface="Arial"/>
               </a:rPr>
-              <a:t>The fraud engine flags claims with missing GPS coordinates (+15 pts), zero damage annotations (+20 pts), delayed reporting &gt;14 days (+20 pts), repeat plate history, or location mismatches.</a:t>
+              <a:t>A 15-second background watchdog computes elapsed minutes for all pending claims and underwriting policies. Any file &gt;=60 minutes turns crimson RED at the top of the Dashboard and fires an SLA Breach email.</a:t>
             </a:r>
           </a:p>
         </p:txBody>
@@ -12144,7 +12144,7 @@
                 </a:solidFill>
                 <a:latin typeface="Courier New"/>
               </a:rPr>
-              <a:t>STEP 3 · GIS GEOMAP CENTER</a:t>
+              <a:t>EXECUTIVE ACTION &amp; SLA TESTING</a:t>
             </a:r>
           </a:p>
           <a:p>
@@ -12160,7 +12160,7 @@
                 </a:solidFill>
                 <a:latin typeface="Arial"/>
               </a:rPr>
-              <a:t>Real-Time Dispatch Across Kenya Corridors</a:t>
+              <a:t>1-Click 'Approve Now' &amp; '+60m SLA Breach' Simulator</a:t>
             </a:r>
           </a:p>
           <a:p>
@@ -12176,7 +12176,7 @@
                 </a:solidFill>
                 <a:latin typeface="Arial"/>
               </a:rPr>
-              <a:t>Interactive Leaflet/OpenStreetMap command view tracking active incidents, SIU red-path alerts, accredited repair garages, and mobile tow units across Nairobi, Mombasa Road, Nakuru, and Kisumu.</a:t>
+              <a:t>Executives can approve individual overdue items or clear the entire queue in one click directly from the red Dashboard banner, or click 'Simulate +60m SLA Breach' to test immediate escalation on new items.</a:t>
             </a:r>
           </a:p>
         </p:txBody>
@@ -12565,7 +12565,7 @@
                 </a:solidFill>
                 <a:latin typeface="Arial"/>
               </a:rPr>
-              <a:t>5 Core Design Decisions</a:t>
+              <a:t>6 Core Design Decisions</a:t>
             </a:r>
           </a:p>
         </p:txBody>
@@ -12652,7 +12652,7 @@
                 </a:solidFill>
                 <a:latin typeface="Arial"/>
               </a:rPr>
-              <a:t>4 Roles &amp; 24 Portal Modules</a:t>
+              <a:t>7 Domains &amp; 25 Modules</a:t>
             </a:r>
           </a:p>
         </p:txBody>
@@ -12703,7 +12703,7 @@
                 </a:solidFill>
                 <a:latin typeface="Arial"/>
               </a:rPr>
-              <a:t>FNOL Triage &amp; GIS Telemetry</a:t>
+              <a:t>Claim Alerts &amp; 60m Red SLA</a:t>
             </a:r>
           </a:p>
         </p:txBody>
@@ -12754,7 +12754,7 @@
                 </a:solidFill>
                 <a:latin typeface="Arial"/>
               </a:rPr>
-              <a:t>5-Stage Garage &amp; Subrogation</a:t>
+              <a:t>Underwriting Email &amp; EV Desk</a:t>
             </a:r>
           </a:p>
         </p:txBody>
@@ -12805,7 +12805,7 @@
                 </a:solidFill>
                 <a:latin typeface="Arial"/>
               </a:rPr>
-              <a:t>3-Sticker AKI QR Certificate</a:t>
+              <a:t>Garages, Subrogation &amp; QR</a:t>
             </a:r>
           </a:p>
         </p:txBody>
@@ -12892,7 +12892,7 @@
                 </a:solidFill>
                 <a:latin typeface="Arial"/>
               </a:rPr>
-              <a:t>4-Layer Cloud Architecture</a:t>
+              <a:t>4-Layer Cloud &amp; Telemetry</a:t>
             </a:r>
           </a:p>
         </p:txBody>
@@ -12943,7 +12943,7 @@
                 </a:solidFill>
                 <a:latin typeface="Arial"/>
               </a:rPr>
-              <a:t>Zero-Trust &amp; Cap 487 Model</a:t>
+              <a:t>Zero-Trust &amp; Cap 487 Tax</a:t>
             </a:r>
           </a:p>
         </p:txBody>
@@ -12994,7 +12994,7 @@
                 </a:solidFill>
                 <a:latin typeface="Arial"/>
               </a:rPr>
-              <a:t>Governance &amp; 4 Licensing Tiers</a:t>
+              <a:t>Reinsurance &amp; Pricing Tiers</a:t>
             </a:r>
           </a:p>
         </p:txBody>
@@ -13030,7 +13030,7 @@
                 </a:solidFill>
                 <a:latin typeface="Arial"/>
               </a:rPr>
-              <a:t>IV. AI, ROADMAP &amp; IMPACT</a:t>
+              <a:t>IV. AI, GOD MODE &amp; IMPACT</a:t>
             </a:r>
           </a:p>
         </p:txBody>
@@ -13081,7 +13081,7 @@
                 </a:solidFill>
                 <a:latin typeface="Arial"/>
               </a:rPr>
-              <a:t>Gemini AI Copilot &amp; Guardrails</a:t>
+              <a:t>Reports AI Analytics Tool</a:t>
             </a:r>
           </a:p>
         </p:txBody>
@@ -13132,7 +13132,7 @@
                 </a:solidFill>
                 <a:latin typeface="Arial"/>
               </a:rPr>
-              <a:t>36-Mo Roadmap &amp; Targets</a:t>
+              <a:t>God Mode &amp; 36-Mo Roadmap</a:t>
             </a:r>
           </a:p>
         </p:txBody>
@@ -13174,7 +13174,7 @@
                 </a:solidFill>
                 <a:latin typeface="Arial"/>
               </a:rPr>
-              <a:t>SLIDE 06 · 5-STAGE GARAGE &amp; SUBROGATION</a:t>
+              <a:t>SLIDE 06 · UNDERWRITING EMAIL &amp; EV DESK</a:t>
             </a:r>
           </a:p>
         </p:txBody>
@@ -13210,7 +13210,7 @@
                 </a:solidFill>
                 <a:latin typeface="Arial"/>
               </a:rPr>
-              <a:t>Accredited Garage SLA Tracking &amp; Subrogation Recovery</a:t>
+              <a:t>New Underwriting Email Notifications, County Fleet &amp; EV Tariffing</a:t>
             </a:r>
           </a:p>
           <a:p>
@@ -13226,7 +13226,7 @@
                 </a:solidFill>
                 <a:latin typeface="Arial"/>
               </a:rPr>
-              <a:t>End-to-end post-approval repair governance, digital release vouchers, salvage disposal, and third-party insurer recovery.</a:t>
+              <a:t>Whenever a new Motor, County Fleet, or Electric Vehicle policy is underwritten, a notification email is automatically dispatched to designated underwriting recipients.</a:t>
             </a:r>
           </a:p>
         </p:txBody>
@@ -13268,7 +13268,7 @@
                 </a:solidFill>
                 <a:latin typeface="Arial"/>
               </a:rPr>
-              <a:t>5 Stages</a:t>
+              <a:t>100% Notified</a:t>
             </a:r>
           </a:p>
           <a:p>
@@ -13284,7 +13284,7 @@
                 </a:solidFill>
                 <a:latin typeface="Arial"/>
               </a:rPr>
-              <a:t>INTAKE TO QA PASS MILESTONES</a:t>
+              <a:t>NEW UNDERWRITING EMAIL DISPATCH</a:t>
             </a:r>
           </a:p>
         </p:txBody>
@@ -13326,7 +13326,7 @@
                 </a:solidFill>
                 <a:latin typeface="Arial"/>
               </a:rPr>
-              <a:t>KSh 4.85M</a:t>
+              <a:t>-15% Rebate</a:t>
             </a:r>
           </a:p>
           <a:p>
@@ -13342,7 +13342,7 @@
                 </a:solidFill>
                 <a:latin typeface="Arial"/>
               </a:rPr>
-              <a:t>ACTIVE SUBROGATION PIPELINE</a:t>
+              <a:t>EV ADAS &amp; THERMAL DISCOUNTS</a:t>
             </a:r>
           </a:p>
         </p:txBody>
@@ -13384,7 +13384,7 @@
                 </a:solidFill>
                 <a:latin typeface="Arial"/>
               </a:rPr>
-              <a:t>KSh 1.24M</a:t>
+              <a:t>47 Counties</a:t>
             </a:r>
           </a:p>
           <a:p>
@@ -13400,7 +13400,7 @@
                 </a:solidFill>
                 <a:latin typeface="Arial"/>
               </a:rPr>
-              <a:t>SETTLED THIRD-PARTY RECOVERIES</a:t>
+              <a:t>BULK CSV FLEET UNDERWRITING</a:t>
             </a:r>
           </a:p>
         </p:txBody>
@@ -13442,7 +13442,7 @@
                 </a:solidFill>
                 <a:latin typeface="Arial"/>
               </a:rPr>
-              <a:t>22%+ Target</a:t>
+              <a:t>AKI Certs</a:t>
             </a:r>
           </a:p>
           <a:p>
@@ -13458,7 +13458,7 @@
                 </a:solidFill>
                 <a:latin typeface="Arial"/>
               </a:rPr>
-              <a:t>SIU INDEMNITY RECOVERY RATIO</a:t>
+              <a:t>INSTANT 3-STICKER &amp; QR ISSUE</a:t>
             </a:r>
           </a:p>
         </p:txBody>
@@ -13500,7 +13500,7 @@
                 </a:solidFill>
                 <a:latin typeface="Courier New"/>
               </a:rPr>
-              <a:t>ACCREDITED GARAGE NETWORK</a:t>
+              <a:t>AUTOMATED UNDERWRITING EMAIL HOOKS</a:t>
             </a:r>
           </a:p>
           <a:p>
@@ -13516,7 +13516,7 @@
                 </a:solidFill>
                 <a:latin typeface="Arial"/>
               </a:rPr>
-              <a:t>5-Stage Milestone Tracker &amp; 5% KRA WHT</a:t>
+              <a:t>Instant Notification Across All Underwriting Flows</a:t>
             </a:r>
           </a:p>
           <a:p>
@@ -13532,7 +13532,7 @@
                 </a:solidFill>
                 <a:latin typeface="Arial"/>
               </a:rPr>
-              <a:t>Real-time work orders across Nairobi Auto Care, Coast Breakdown, Lakeside Motors, and Rift Valley Clinic. Digital repair release vouchers automatically compute 5% KRA Withholding Tax.</a:t>
+              <a:t>Whether creating a policy in Policy Registry (confirmCreateNewPolicy), issuing an EV Certificate (issueEVPolicyCertificate), or activating an inline certificate, EIMS emails underwriting@eims-prosystem.go.ke immediately.</a:t>
             </a:r>
           </a:p>
         </p:txBody>
@@ -13574,7 +13574,7 @@
                 </a:solidFill>
                 <a:latin typeface="Courier New"/>
               </a:rPr>
-              <a:t>SUBROGATION &amp; LEGAL RECOVERY</a:t>
+              <a:t>INTERNATIONAL EV ACTUARIAL CALCULATOR</a:t>
             </a:r>
           </a:p>
           <a:p>
@@ -13590,7 +13590,7 @@
                 </a:solidFill>
                 <a:latin typeface="Arial"/>
               </a:rPr>
-              <a:t>Automated Third-Party Insurer Demand Tracking</a:t>
+              <a:t>HV Battery Scarcity Loading &amp; Telemetry Rebates</a:t>
             </a:r>
           </a:p>
           <a:p>
@@ -13606,7 +13606,7 @@
                 </a:solidFill>
                 <a:latin typeface="Arial"/>
               </a:rPr>
-              <a:t>Tracks fault liability, demand letters, arbitration status, and recovery receipts against negligent third-party underwriters—shortening liability assignment by an average of 18 days.</a:t>
+              <a:t>Computes specialized Electric Vehicle premiums (BYD Atto 3, Tesla Model Y, Roam Air, BasiGo E9) factoring 3.50% base rate, +15% HV battery loading, -12.5% low-mileage telemetry rebate, and -15% ADAS safety discounts.</a:t>
             </a:r>
           </a:p>
         </p:txBody>
@@ -13648,7 +13648,7 @@
                 </a:solidFill>
                 <a:latin typeface="Courier New"/>
               </a:rPr>
-              <a:t>SALVAGE ASSET DISPOSAL</a:t>
+              <a:t>CONFIGURABLE DESIGNATED RECIPIENTS</a:t>
             </a:r>
           </a:p>
           <a:p>
@@ -13664,7 +13664,7 @@
                 </a:solidFill>
                 <a:latin typeface="Arial"/>
               </a:rPr>
-              <a:t>Total-Loss Wreckage Valuation &amp; Auction Ledger</a:t>
+              <a:t>Live Email Recipient Bar &amp; Multi-Channel Audit Log</a:t>
             </a:r>
           </a:p>
           <a:p>
@@ -13680,7 +13680,7 @@
                 </a:solidFill>
                 <a:latin typeface="Arial"/>
               </a:rPr>
-              <a:t>Catalogs write-off vehicles, reserve prices, and highest auction bids (KSh 890,000 recovered across 3 disposed total-loss salvages) to offset gross claim indemnity.</a:t>
+              <a:t>Under Notification Simulator, administrators can customize comma-separated designated email addresses, test 'Claim Awaiting Approval' and 'New Underwriting' emails, and inspect the SMTP 250 OK audit table.</a:t>
             </a:r>
           </a:p>
         </p:txBody>
@@ -14069,7 +14069,7 @@
                 </a:solidFill>
                 <a:latin typeface="Arial"/>
               </a:rPr>
-              <a:t>5 Core Design Decisions</a:t>
+              <a:t>6 Core Design Decisions</a:t>
             </a:r>
           </a:p>
         </p:txBody>
@@ -14156,7 +14156,7 @@
                 </a:solidFill>
                 <a:latin typeface="Arial"/>
               </a:rPr>
-              <a:t>4 Roles &amp; 24 Portal Modules</a:t>
+              <a:t>7 Domains &amp; 25 Modules</a:t>
             </a:r>
           </a:p>
         </p:txBody>
@@ -14207,7 +14207,7 @@
                 </a:solidFill>
                 <a:latin typeface="Arial"/>
               </a:rPr>
-              <a:t>FNOL Triage &amp; GIS Telemetry</a:t>
+              <a:t>Claim Alerts &amp; 60m Red SLA</a:t>
             </a:r>
           </a:p>
         </p:txBody>
@@ -14258,7 +14258,7 @@
                 </a:solidFill>
                 <a:latin typeface="Arial"/>
               </a:rPr>
-              <a:t>5-Stage Garage &amp; Subrogation</a:t>
+              <a:t>Underwriting Email &amp; EV Desk</a:t>
             </a:r>
           </a:p>
         </p:txBody>
@@ -14309,7 +14309,7 @@
                 </a:solidFill>
                 <a:latin typeface="Arial"/>
               </a:rPr>
-              <a:t>3-Sticker AKI QR Certificate</a:t>
+              <a:t>Garages, Subrogation &amp; QR</a:t>
             </a:r>
           </a:p>
         </p:txBody>
@@ -14396,7 +14396,7 @@
                 </a:solidFill>
                 <a:latin typeface="Arial"/>
               </a:rPr>
-              <a:t>4-Layer Cloud Architecture</a:t>
+              <a:t>4-Layer Cloud &amp; Telemetry</a:t>
             </a:r>
           </a:p>
         </p:txBody>
@@ -14447,7 +14447,7 @@
                 </a:solidFill>
                 <a:latin typeface="Arial"/>
               </a:rPr>
-              <a:t>Zero-Trust &amp; Cap 487 Model</a:t>
+              <a:t>Zero-Trust &amp; Cap 487 Tax</a:t>
             </a:r>
           </a:p>
         </p:txBody>
@@ -14498,7 +14498,7 @@
                 </a:solidFill>
                 <a:latin typeface="Arial"/>
               </a:rPr>
-              <a:t>Governance &amp; 4 Licensing Tiers</a:t>
+              <a:t>Reinsurance &amp; Pricing Tiers</a:t>
             </a:r>
           </a:p>
         </p:txBody>
@@ -14534,7 +14534,7 @@
                 </a:solidFill>
                 <a:latin typeface="Arial"/>
               </a:rPr>
-              <a:t>IV. AI, ROADMAP &amp; IMPACT</a:t>
+              <a:t>IV. AI, GOD MODE &amp; IMPACT</a:t>
             </a:r>
           </a:p>
         </p:txBody>
@@ -14585,7 +14585,7 @@
                 </a:solidFill>
                 <a:latin typeface="Arial"/>
               </a:rPr>
-              <a:t>Gemini AI Copilot &amp; Guardrails</a:t>
+              <a:t>Reports AI Analytics Tool</a:t>
             </a:r>
           </a:p>
         </p:txBody>
@@ -14636,7 +14636,7 @@
                 </a:solidFill>
                 <a:latin typeface="Arial"/>
               </a:rPr>
-              <a:t>36-Mo Roadmap &amp; Targets</a:t>
+              <a:t>God Mode &amp; 36-Mo Roadmap</a:t>
             </a:r>
           </a:p>
         </p:txBody>
@@ -14678,7 +14678,7 @@
                 </a:solidFill>
                 <a:latin typeface="Arial"/>
               </a:rPr>
-              <a:t>SLIDE 07 · 3-STICKER AKI QR CERTIFICATE</a:t>
+              <a:t>SLIDE 07 · GARAGES, SUBROGATION &amp; QR</a:t>
             </a:r>
           </a:p>
         </p:txBody>
@@ -14714,7 +14714,7 @@
                 </a:solidFill>
                 <a:latin typeface="Arial"/>
               </a:rPr>
-              <a:t>Kenyan 3-Part Windshield Certificate &amp; Public QR Verifier</a:t>
+              <a:t>5-Stage Garage SLA, Subrogation Recovery &amp; Scannable QR Engine</a:t>
             </a:r>
           </a:p>
           <a:p>
@@ -14730,7 +14730,7 @@
                 </a:solidFill>
                 <a:latin typeface="Arial"/>
               </a:rPr>
-              <a:t>Compliant with Motor Vehicles Third Party Risks Act (Cap 405) &amp; Association of Kenya Insurers (AKI) digital registry standards.</a:t>
+              <a:t>End-to-end post-approval repair governance, third-party liability recovery, and cryptographic NTSA / Kenya Police roadside QR verification.</a:t>
             </a:r>
           </a:p>
         </p:txBody>
@@ -14772,7 +14772,7 @@
                 </a:solidFill>
                 <a:latin typeface="Arial"/>
               </a:rPr>
-              <a:t>3 Stickers</a:t>
+              <a:t>5 Stages</a:t>
             </a:r>
           </a:p>
           <a:p>
@@ -14788,7 +14788,7 @@
                 </a:solidFill>
                 <a:latin typeface="Arial"/>
               </a:rPr>
-              <a:t>FILE COPY + DUPLICATE + ORIGINAL</a:t>
+              <a:t>INTAKE TO QA PASS MILESTONES</a:t>
             </a:r>
           </a:p>
         </p:txBody>
@@ -14830,7 +14830,7 @@
                 </a:solidFill>
                 <a:latin typeface="Arial"/>
               </a:rPr>
-              <a:t>85px x 85px</a:t>
+              <a:t>KSh 4.85M</a:t>
             </a:r>
           </a:p>
           <a:p>
@@ -14846,7 +14846,7 @@
                 </a:solidFill>
                 <a:latin typeface="Arial"/>
               </a:rPr>
-              <a:t>SCANNABLE QR CONTAINER</a:t>
+              <a:t>ACTIVE SUBROGATION PIPELINE</a:t>
             </a:r>
           </a:p>
         </p:txBody>
@@ -14888,7 +14888,7 @@
                 </a:solidFill>
                 <a:latin typeface="Arial"/>
               </a:rPr>
-              <a:t>SHA-256</a:t>
+              <a:t>85px x 85px</a:t>
             </a:r>
           </a:p>
           <a:p>
@@ -14904,7 +14904,7 @@
                 </a:solidFill>
                 <a:latin typeface="Arial"/>
               </a:rPr>
-              <a:t>CRYPTOGRAPHIC ANTI-TAMPER SEAL</a:t>
+              <a:t>3-STICKER AKI &amp; NTSA QR BADGES</a:t>
             </a:r>
           </a:p>
         </p:txBody>
@@ -14946,7 +14946,7 @@
                 </a:solidFill>
                 <a:latin typeface="Arial"/>
               </a:rPr>
-              <a:t>Public URL</a:t>
+              <a:t>98.8% OCR</a:t>
             </a:r>
           </a:p>
           <a:p>
@@ -14962,7 +14962,7 @@
                 </a:solidFill>
                 <a:latin typeface="Arial"/>
               </a:rPr>
-              <a:t>/?VERIFYCERT=TRUE MOBILE SCAN</a:t>
+              <a:t>CNN KENYAN PLATE RECOGNITION</a:t>
             </a:r>
           </a:p>
         </p:txBody>
@@ -15004,7 +15004,7 @@
                 </a:solidFill>
                 <a:latin typeface="Courier New"/>
               </a:rPr>
-              <a:t>KENYAN WINDSHIELD STANDARD</a:t>
+              <a:t>ACCREDITED GARAGE &amp; ASSESSOR NETWORK</a:t>
             </a:r>
           </a:p>
           <a:p>
@@ -15020,7 +15020,7 @@
                 </a:solidFill>
                 <a:latin typeface="Arial"/>
               </a:rPr>
-              <a:t>Side-by-Side 3-Copy Certificate Layout</a:t>
+              <a:t>5-Stage Work Orders, Loss Assessors &amp; 5% KRA WHT</a:t>
             </a:r>
           </a:p>
           <a:p>
@@ -15036,7 +15036,7 @@
                 </a:solidFill>
                 <a:latin typeface="Arial"/>
               </a:rPr>
-              <a:t>Renders the official green/white 3-sticker layout (File Copy, Duplicate, and Original Certificate of Insurance) synchronized dynamically with Policyholder, Policy No, Validity Dates, Registration Plate, and Chassis.</a:t>
+              <a:t>Assigns claims to accredited panel beaters and loss assessors/SIU investigators, tracks 5-stage repair milestones, and generates digital release vouchers with automatic 5% KRA Withholding Tax deduction.</a:t>
             </a:r>
           </a:p>
         </p:txBody>
@@ -15078,7 +15078,7 @@
                 </a:solidFill>
                 <a:latin typeface="Courier New"/>
               </a:rPr>
-              <a:t>INSTANT CAMERA SCAN VERIFICATION</a:t>
+              <a:t>SUBROGATION RECOVERY LEDGER</a:t>
             </a:r>
           </a:p>
           <a:p>
@@ -15094,7 +15094,7 @@
                 </a:solidFill>
                 <a:latin typeface="Arial"/>
               </a:rPr>
-              <a:t>Zero-App Smartphone &amp; Traffic Police Scanning</a:t>
+              <a:t>Third-Party Insurer Demand &amp; Arbitration Tracking</a:t>
             </a:r>
           </a:p>
           <a:p>
@@ -15110,7 +15110,7 @@
                 </a:solidFill>
                 <a:latin typeface="Arial"/>
               </a:rPr>
-              <a:t>Scanning the embedded 85px QR code with any mobile camera opens /?verifyCert=true, triggering the Public Verification Modal with live AKI registry status, vehicle plate, and SHA-256 hash.</a:t>
+              <a:t>Pursues negligent third-party insurers across active recovery files, automating legal demand notice generation and tracking recovered indemnity funds back into the claims reserve.</a:t>
             </a:r>
           </a:p>
         </p:txBody>
@@ -15152,7 +15152,7 @@
                 </a:solidFill>
                 <a:latin typeface="Courier New"/>
               </a:rPr>
-              <a:t>IMMUTABLE ANTI-TAMPER PROTECTION</a:t>
+              <a:t>DYNAMIC QR ENGINE &amp; NTSA POLICE BADGE</a:t>
             </a:r>
           </a:p>
           <a:p>
@@ -15168,7 +15168,7 @@
                 </a:solidFill>
                 <a:latin typeface="Arial"/>
               </a:rPr>
-              <a:t>Fraudulent Edit Detection &amp; Integrity Audit</a:t>
+              <a:t>100% Smartphone-Scannable Verification Badges</a:t>
             </a:r>
           </a:p>
           <a:p>
@@ -15184,7 +15184,7 @@
                 </a:solidFill>
                 <a:latin typeface="Arial"/>
               </a:rPr>
-              <a:t>Includes built-in SHA-256 integrity auditing and tamper simulation—automatically revoking certificate validity if unauthorized DOM or payload mutation is detected.</a:t>
+              <a:t>Generates high-contrast scannable QR codes for AKI 3-part windshield stickers and official 'SCAN TO VERIFY - NTSA / Police Verified' badges with live camera/verifier testing.</a:t>
             </a:r>
           </a:p>
         </p:txBody>
@@ -15573,7 +15573,7 @@
                 </a:solidFill>
                 <a:latin typeface="Arial"/>
               </a:rPr>
-              <a:t>5 Core Design Decisions</a:t>
+              <a:t>6 Core Design Decisions</a:t>
             </a:r>
           </a:p>
         </p:txBody>
@@ -15660,7 +15660,7 @@
                 </a:solidFill>
                 <a:latin typeface="Arial"/>
               </a:rPr>
-              <a:t>4 Roles &amp; 24 Portal Modules</a:t>
+              <a:t>7 Domains &amp; 25 Modules</a:t>
             </a:r>
           </a:p>
         </p:txBody>
@@ -15711,7 +15711,7 @@
                 </a:solidFill>
                 <a:latin typeface="Arial"/>
               </a:rPr>
-              <a:t>FNOL Triage &amp; GIS Telemetry</a:t>
+              <a:t>Claim Alerts &amp; 60m Red SLA</a:t>
             </a:r>
           </a:p>
         </p:txBody>
@@ -15762,7 +15762,7 @@
                 </a:solidFill>
                 <a:latin typeface="Arial"/>
               </a:rPr>
-              <a:t>5-Stage Garage &amp; Subrogation</a:t>
+              <a:t>Underwriting Email &amp; EV Desk</a:t>
             </a:r>
           </a:p>
         </p:txBody>
@@ -15813,7 +15813,7 @@
                 </a:solidFill>
                 <a:latin typeface="Arial"/>
               </a:rPr>
-              <a:t>3-Sticker AKI QR Certificate</a:t>
+              <a:t>Garages, Subrogation &amp; QR</a:t>
             </a:r>
           </a:p>
         </p:txBody>
@@ -15900,7 +15900,7 @@
                 </a:solidFill>
                 <a:latin typeface="Arial"/>
               </a:rPr>
-              <a:t>4-Layer Cloud Architecture</a:t>
+              <a:t>4-Layer Cloud &amp; Telemetry</a:t>
             </a:r>
           </a:p>
         </p:txBody>
@@ -15951,7 +15951,7 @@
                 </a:solidFill>
                 <a:latin typeface="Arial"/>
               </a:rPr>
-              <a:t>Zero-Trust &amp; Cap 487 Model</a:t>
+              <a:t>Zero-Trust &amp; Cap 487 Tax</a:t>
             </a:r>
           </a:p>
         </p:txBody>
@@ -16002,7 +16002,7 @@
                 </a:solidFill>
                 <a:latin typeface="Arial"/>
               </a:rPr>
-              <a:t>Governance &amp; 4 Licensing Tiers</a:t>
+              <a:t>Reinsurance &amp; Pricing Tiers</a:t>
             </a:r>
           </a:p>
         </p:txBody>
@@ -16038,7 +16038,7 @@
                 </a:solidFill>
                 <a:latin typeface="Arial"/>
               </a:rPr>
-              <a:t>IV. AI, ROADMAP &amp; IMPACT</a:t>
+              <a:t>IV. AI, GOD MODE &amp; IMPACT</a:t>
             </a:r>
           </a:p>
         </p:txBody>
@@ -16089,7 +16089,7 @@
                 </a:solidFill>
                 <a:latin typeface="Arial"/>
               </a:rPr>
-              <a:t>Gemini AI Copilot &amp; Guardrails</a:t>
+              <a:t>Reports AI Analytics Tool</a:t>
             </a:r>
           </a:p>
         </p:txBody>
@@ -16140,7 +16140,7 @@
                 </a:solidFill>
                 <a:latin typeface="Arial"/>
               </a:rPr>
-              <a:t>36-Mo Roadmap &amp; Targets</a:t>
+              <a:t>God Mode &amp; 36-Mo Roadmap</a:t>
             </a:r>
           </a:p>
         </p:txBody>
@@ -16182,7 +16182,7 @@
                 </a:solidFill>
                 <a:latin typeface="Arial"/>
               </a:rPr>
-              <a:t>SLIDE 08 · 4-LAYER CLOUD ARCHITECTURE</a:t>
+              <a:t>SLIDE 08 · 4-LAYER CLOUD &amp; TELEMETRY</a:t>
             </a:r>
           </a:p>
         </p:txBody>
@@ -16218,7 +16218,7 @@
                 </a:solidFill>
                 <a:latin typeface="Arial"/>
               </a:rPr>
-              <a:t>Serverless Firebase, Next.js &amp; Capacitor Hybrid Stack</a:t>
+              <a:t>Serverless Firebase Hosting, Cloud Functions &amp; Telemetry Stack</a:t>
             </a:r>
           </a:p>
           <a:p>
@@ -16234,7 +16234,7 @@
                 </a:solidFill>
                 <a:latin typeface="Arial"/>
               </a:rPr>
-              <a:t>Engineered for sub-second interactivity, offline-capable field operations, and zero-downtime static + serverless scaling.</a:t>
+              <a:t>Deployed live at https://eims-prosystem.web.app with sub-second interactivity, persistent local + Firestore state, and multi-channel notification dispatch.</a:t>
             </a:r>
           </a:p>
         </p:txBody>
@@ -16292,7 +16292,7 @@
                 </a:solidFill>
                 <a:latin typeface="Arial"/>
               </a:rPr>
-              <a:t>PWA, EDGE CDN, FUNCTIONS, DB</a:t>
+              <a:t>SPA/NEXT.JS, CDN, FUNCTIONS, DB</a:t>
             </a:r>
           </a:p>
         </p:txBody>
@@ -16334,7 +16334,7 @@
                 </a:solidFill>
                 <a:latin typeface="Arial"/>
               </a:rPr>
-              <a:t>0 Idle Recalcs</a:t>
+              <a:t>3 Channels</a:t>
             </a:r>
           </a:p>
           <a:p>
@@ -16350,7 +16350,7 @@
                 </a:solidFill>
                 <a:latin typeface="Arial"/>
               </a:rPr>
-              <a:t>GPU-CLEAN CSS PERFORMANCE</a:t>
+              <a:t>RICH EMAIL, WHATSAPP &amp; SMS</a:t>
             </a:r>
           </a:p>
         </p:txBody>
@@ -16392,7 +16392,7 @@
                 </a:solidFill>
                 <a:latin typeface="Arial"/>
               </a:rPr>
-              <a:t>6 Collections</a:t>
+              <a:t>0 Idle Recalcs</a:t>
             </a:r>
           </a:p>
           <a:p>
@@ -16408,7 +16408,7 @@
                 </a:solidFill>
                 <a:latin typeface="Arial"/>
               </a:rPr>
-              <a:t>REAL-TIME FIRESTORE LISTENERS</a:t>
+              <a:t>GPU-CLEAN DARK &amp; ORANGE UI</a:t>
             </a:r>
           </a:p>
         </p:txBody>
@@ -16450,7 +16450,7 @@
                 </a:solidFill>
                 <a:latin typeface="Arial"/>
               </a:rPr>
-              <a:t>Android APK</a:t>
+              <a:t>PWA + APK</a:t>
             </a:r>
           </a:p>
           <a:p>
@@ -16466,7 +16466,7 @@
                 </a:solidFill>
                 <a:latin typeface="Arial"/>
               </a:rPr>
-              <a:t>CAPACITOR 8.5 NATIVE MOBILE</a:t>
+              <a:t>WEB APP &amp; CAPACITOR ANDROID</a:t>
             </a:r>
           </a:p>
         </p:txBody>
@@ -16508,7 +16508,7 @@
                 </a:solidFill>
                 <a:latin typeface="Courier New"/>
               </a:rPr>
-              <a:t>LAYER 1 &amp; 2 · PRESENTATION &amp; EDGE</a:t>
+              <a:t>LAYER 1 &amp; 2 · PRESENTATION &amp; FIREBASE CDN</a:t>
             </a:r>
           </a:p>
           <a:p>
@@ -16524,7 +16524,7 @@
                 </a:solidFill>
                 <a:latin typeface="Arial"/>
               </a:rPr>
-              <a:t>Dual SPA / Next.js 16 + Firebase Hosting CDN</a:t>
+              <a:t>High-Contrast Orange &amp; Obsidian Black Enterprise UI</a:t>
             </a:r>
           </a:p>
           <a:p>
@@ -16540,7 +16540,7 @@
                 </a:solidFill>
                 <a:latin typeface="Arial"/>
               </a:rPr>
-              <a:t>Ships a zero-latency 24-view portal alongside a modular Next.js App Router build and Capacitor Android wrapper, served globally over Firebase Hosting with strict no-cache JS/CSS headers.</a:t>
+              <a:t>Engineered with a sleek obsidian-black and vibrant orange (#ff6b00) design system, responsive mobile drawer, and global Firebase Hosting CDN deployment.</a:t>
             </a:r>
           </a:p>
         </p:txBody>
@@ -16582,7 +16582,7 @@
                 </a:solidFill>
                 <a:latin typeface="Courier New"/>
               </a:rPr>
-              <a:t>LAYER 3 · SERVERLESS DOMAIN ENGINE</a:t>
+              <a:t>LAYER 3 · SERVERLESS DOMAIN &amp; EMAIL ENGINE</a:t>
             </a:r>
           </a:p>
           <a:p>
@@ -16598,7 +16598,7 @@
                 </a:solidFill>
                 <a:latin typeface="Arial"/>
               </a:rPr>
-              <a:t>Firebase Cloud Functions (backend/functions/rules.js)</a:t>
+              <a:t>Deterministic Fraud, Statutory Math &amp; Email Relay</a:t>
             </a:r>
           </a:p>
           <a:p>
@@ -16614,7 +16614,7 @@
                 </a:solidFill>
                 <a:latin typeface="Arial"/>
               </a:rPr>
-              <a:t>Executes authoritative server-side fraud scoring (scoreFraud), statutory tax calculation (statutoryTax), and settlement eligibility gating (canSettle) before ledger mutation.</a:t>
+              <a:t>Executes authoritative fraud scoring, IRA Cap 487 statutory levy math, and automated SMTP/SendGrid email dispatch for pending claim approvals, new underwritings, and 60-minute SLA escalations.</a:t>
             </a:r>
           </a:p>
         </p:txBody>
@@ -16656,7 +16656,7 @@
                 </a:solidFill>
                 <a:latin typeface="Courier New"/>
               </a:rPr>
-              <a:t>LAYER 4 · REAL-TIME PERSISTENCE</a:t>
+              <a:t>LAYER 4 · REAL-TIME PERSISTENCE &amp; AUDIT TRAIL</a:t>
             </a:r>
           </a:p>
           <a:p>
@@ -16672,7 +16672,7 @@
                 </a:solidFill>
                 <a:latin typeface="Arial"/>
               </a:rPr>
-              <a:t>Cloud Firestore + Multi-Tenant Routing</a:t>
+              <a:t>Firestore Collections + LocalStorage Continuity</a:t>
             </a:r>
           </a:p>
           <a:p>
@@ -16688,7 +16688,7 @@
                 </a:solidFill>
                 <a:latin typeface="Arial"/>
               </a:rPr>
-              <a:t>Real-time synchronization across claims, policies, certificates, notification_logs, work_orders, and user_seats with automatic fallback to deterministic local seed datasets.</a:t>
+              <a:t>Synchronizes claims, policies, certificates, notification_logs, designated_emails, and God Mode telemetry with instant local persistence so no state is lost across sessions.</a:t>
             </a:r>
           </a:p>
         </p:txBody>
@@ -17077,7 +17077,7 @@
                 </a:solidFill>
                 <a:latin typeface="Arial"/>
               </a:rPr>
-              <a:t>5 Core Design Decisions</a:t>
+              <a:t>6 Core Design Decisions</a:t>
             </a:r>
           </a:p>
         </p:txBody>
@@ -17164,7 +17164,7 @@
                 </a:solidFill>
                 <a:latin typeface="Arial"/>
               </a:rPr>
-              <a:t>4 Roles &amp; 24 Portal Modules</a:t>
+              <a:t>7 Domains &amp; 25 Modules</a:t>
             </a:r>
           </a:p>
         </p:txBody>
@@ -17215,7 +17215,7 @@
                 </a:solidFill>
                 <a:latin typeface="Arial"/>
               </a:rPr>
-              <a:t>FNOL Triage &amp; GIS Telemetry</a:t>
+              <a:t>Claim Alerts &amp; 60m Red SLA</a:t>
             </a:r>
           </a:p>
         </p:txBody>
@@ -17266,7 +17266,7 @@
                 </a:solidFill>
                 <a:latin typeface="Arial"/>
               </a:rPr>
-              <a:t>5-Stage Garage &amp; Subrogation</a:t>
+              <a:t>Underwriting Email &amp; EV Desk</a:t>
             </a:r>
           </a:p>
         </p:txBody>
@@ -17317,7 +17317,7 @@
                 </a:solidFill>
                 <a:latin typeface="Arial"/>
               </a:rPr>
-              <a:t>3-Sticker AKI QR Certificate</a:t>
+              <a:t>Garages, Subrogation &amp; QR</a:t>
             </a:r>
           </a:p>
         </p:txBody>
@@ -17404,7 +17404,7 @@
                 </a:solidFill>
                 <a:latin typeface="Arial"/>
               </a:rPr>
-              <a:t>4-Layer Cloud Architecture</a:t>
+              <a:t>4-Layer Cloud &amp; Telemetry</a:t>
             </a:r>
           </a:p>
         </p:txBody>
@@ -17455,7 +17455,7 @@
                 </a:solidFill>
                 <a:latin typeface="Arial"/>
               </a:rPr>
-              <a:t>Zero-Trust &amp; Cap 487 Model</a:t>
+              <a:t>Zero-Trust &amp; Cap 487 Tax</a:t>
             </a:r>
           </a:p>
         </p:txBody>
@@ -17506,7 +17506,7 @@
                 </a:solidFill>
                 <a:latin typeface="Arial"/>
               </a:rPr>
-              <a:t>Governance &amp; 4 Licensing Tiers</a:t>
+              <a:t>Reinsurance &amp; Pricing Tiers</a:t>
             </a:r>
           </a:p>
         </p:txBody>
@@ -17542,7 +17542,7 @@
                 </a:solidFill>
                 <a:latin typeface="Arial"/>
               </a:rPr>
-              <a:t>IV. AI, ROADMAP &amp; IMPACT</a:t>
+              <a:t>IV. AI, GOD MODE &amp; IMPACT</a:t>
             </a:r>
           </a:p>
         </p:txBody>
@@ -17593,7 +17593,7 @@
                 </a:solidFill>
                 <a:latin typeface="Arial"/>
               </a:rPr>
-              <a:t>Gemini AI Copilot &amp; Guardrails</a:t>
+              <a:t>Reports AI Analytics Tool</a:t>
             </a:r>
           </a:p>
         </p:txBody>
@@ -17644,7 +17644,7 @@
                 </a:solidFill>
                 <a:latin typeface="Arial"/>
               </a:rPr>
-              <a:t>36-Mo Roadmap &amp; Targets</a:t>
+              <a:t>God Mode &amp; 36-Mo Roadmap</a:t>
             </a:r>
           </a:p>
         </p:txBody>
@@ -17686,7 +17686,7 @@
                 </a:solidFill>
                 <a:latin typeface="Arial"/>
               </a:rPr>
-              <a:t>SLIDE 09 · ZERO-TRUST &amp; CAP 487 MODEL</a:t>
+              <a:t>SLIDE 09 · ZERO-TRUST &amp; CAP 487 TAX</a:t>
             </a:r>
           </a:p>
         </p:txBody>
@@ -17722,7 +17722,7 @@
                 </a:solidFill>
                 <a:latin typeface="Arial"/>
               </a:rPr>
-              <a:t>Zero-Trust Firestore Security Rules &amp; Statutory Compliance</a:t>
+              <a:t>Zero-Trust Security Rules, IRA Cap 487 &amp; KRA eTIMS Compliance</a:t>
             </a:r>
           </a:p>
           <a:p>
@@ -17738,7 +17738,7 @@
                 </a:solidFill>
                 <a:latin typeface="Arial"/>
               </a:rPr>
-              <a:t>Production-hardened access control protecting claimant PII while preserving public motor certificate verifiability.</a:t>
+              <a:t>Production-hardened access control paired with automated Kenyan statutory tax computation, e-Citizen SSO, and PesaFlow Paybill 222222 settlement.</a:t>
             </a:r>
           </a:p>
         </p:txBody>
@@ -17796,7 +17796,7 @@
                 </a:solidFill>
                 <a:latin typeface="Arial"/>
               </a:rPr>
-              <a:t>GLOBAL FALLBACK READ/WRITE FALSE</a:t>
+              <a:t>ZERO-TRUST FIRESTORE RULES</a:t>
             </a:r>
           </a:p>
         </p:txBody>
@@ -17838,7 +17838,7 @@
                 </a:solidFill>
                 <a:latin typeface="Arial"/>
               </a:rPr>
-              <a:t>Auth-Gated PII</a:t>
+              <a:t>0.45% + 40</a:t>
             </a:r>
           </a:p>
           <a:p>
@@ -17854,7 +17854,7 @@
                 </a:solidFill>
                 <a:latin typeface="Arial"/>
               </a:rPr>
-              <a:t>/CLAIMS &amp; /POLICIES STAFF ONLY</a:t>
+              <a:t>PHCF + ITL + STAMP DUTY</a:t>
             </a:r>
           </a:p>
         </p:txBody>
@@ -17896,7 +17896,7 @@
                 </a:solidFill>
                 <a:latin typeface="Arial"/>
               </a:rPr>
-              <a:t>Write-Locked</a:t>
+              <a:t>16% &amp; 5%</a:t>
             </a:r>
           </a:p>
           <a:p>
@@ -17912,7 +17912,7 @@
                 </a:solidFill>
                 <a:latin typeface="Arial"/>
               </a:rPr>
-              <a:t>/CERTIFICATES IMMUTABLE PUBLIC</a:t>
+              <a:t>KRA ETIMS VAT &amp; GARAGE WHT</a:t>
             </a:r>
           </a:p>
         </p:txBody>
@@ -17954,7 +17954,7 @@
                 </a:solidFill>
                 <a:latin typeface="Arial"/>
               </a:rPr>
-              <a:t>184% CAR</a:t>
+              <a:t>248% CAR</a:t>
             </a:r>
           </a:p>
           <a:p>
@@ -18044,7 +18044,65 @@
                 </a:solidFill>
                 <a:latin typeface="Arial"/>
               </a:rPr>
-              <a:t>• /claims/{claimId}: Auth required for read/create/update; vehicle string &lt;=20 chars enforced; admin-only delete.</a:t>
+              <a:t>Protects claimant and policyholder PII behind authenticated staff tokens while allowing read-only public verification on /certificates/{certId} for traffic police QR scans.</a:t>
+            </a:r>
+          </a:p>
+        </p:txBody>
+      </p:sp>
+      <p:sp>
+        <p:nvSpPr>
+          <p:cNvPr id="28" name="Card_1"/>
+          <p:cNvSpPr/>
+          <p:nvPr/>
+        </p:nvSpPr>
+        <p:spPr>
+          <a:xfrm>
+            <a:off x="6200000" y="3240000"/>
+            <a:ext cx="2720000" cy="2850000"/>
+          </a:xfrm>
+          <a:prstGeom prst="roundRect">
+            <a:avLst>
+              <a:gd name="adj" fmla="val 8000"/>
+            </a:avLst>
+          </a:prstGeom>
+          <a:solidFill>
+            <a:srgbClr val="110E0B"/>
+          </a:solidFill>
+          <a:ln w="12700">
+            <a:solidFill>
+              <a:srgbClr val="45270A"/>
+            </a:solidFill>
+          </a:ln>
+        </p:spPr>
+        <p:txBody>
+          <a:bodyPr wrap="square" lIns="114300" tIns="91440" rIns="114300" bIns="91440" anchor="t"/>
+          <a:lstStyle/>
+          <a:p>
+            <a:pPr algn="l"/>
+            <a:r>
+              <a:rPr lang="en-US" sz="800" b="1" dirty="0">
+                <a:solidFill>
+                  <a:srgbClr val="F59E0B"/>
+                </a:solidFill>
+                <a:latin typeface="Courier New"/>
+              </a:rPr>
+              <a:t>IRA CAP 487 &amp; KRA ITAX / ETIMS SUITE</a:t>
+            </a:r>
+          </a:p>
+          <a:p>
+            <a:pPr algn="l">
+              <a:spcBef>
+                <a:spcPts val="400"/>
+              </a:spcBef>
+            </a:pPr>
+            <a:r>
+              <a:rPr lang="en-US" sz="1250" b="1" dirty="0">
+                <a:solidFill>
+                  <a:srgbClr val="FFFFFF"/>
+                </a:solidFill>
+                <a:latin typeface="Arial"/>
+              </a:rPr>
+              <a:t>1-Click Statutory Returns &amp; Control Unit Sync</a:t>
             </a:r>
           </a:p>
           <a:p>
@@ -18060,7 +18118,65 @@
                 </a:solidFill>
                 <a:latin typeface="Arial"/>
               </a:rPr>
-              <a:t>• /certificates/{certId}: Public read for roadside QR verification; write locked.</a:t>
+              <a:t>Automatically computes Policyholders Compensation Fund (0.25%), Training Levy (0.20%), Stamp Duty (KSh 40), 16% VAT, and 5% Garage WHT with exportable KIRA Form 104 and KRA eTIMS bulk sync.</a:t>
+            </a:r>
+          </a:p>
+        </p:txBody>
+      </p:sp>
+      <p:sp>
+        <p:nvSpPr>
+          <p:cNvPr id="29" name="Card_2"/>
+          <p:cNvSpPr/>
+          <p:nvPr/>
+        </p:nvSpPr>
+        <p:spPr>
+          <a:xfrm>
+            <a:off x="9100000" y="3240000"/>
+            <a:ext cx="2720000" cy="2850000"/>
+          </a:xfrm>
+          <a:prstGeom prst="roundRect">
+            <a:avLst>
+              <a:gd name="adj" fmla="val 8000"/>
+            </a:avLst>
+          </a:prstGeom>
+          <a:solidFill>
+            <a:srgbClr val="110E0B"/>
+          </a:solidFill>
+          <a:ln w="12700">
+            <a:solidFill>
+              <a:srgbClr val="45270A"/>
+            </a:solidFill>
+          </a:ln>
+        </p:spPr>
+        <p:txBody>
+          <a:bodyPr wrap="square" lIns="114300" tIns="91440" rIns="114300" bIns="91440" anchor="t"/>
+          <a:lstStyle/>
+          <a:p>
+            <a:pPr algn="l"/>
+            <a:r>
+              <a:rPr lang="en-US" sz="800" b="1" dirty="0">
+                <a:solidFill>
+                  <a:srgbClr val="F59E0B"/>
+                </a:solidFill>
+                <a:latin typeface="Courier New"/>
+              </a:rPr>
+              <a:t>E-CITIZEN SSO &amp; PESAFLOW GATEWAY</a:t>
+            </a:r>
+          </a:p>
+          <a:p>
+            <a:pPr algn="l">
+              <a:spcBef>
+                <a:spcPts val="400"/>
+              </a:spcBef>
+            </a:pPr>
+            <a:r>
+              <a:rPr lang="en-US" sz="1250" b="1" dirty="0">
+                <a:solidFill>
+                  <a:srgbClr val="FFFFFF"/>
+                </a:solidFill>
+                <a:latin typeface="Arial"/>
+              </a:rPr>
+              <a:t>Government Paybill 222222 &amp; Multi-Rail Payouts</a:t>
             </a:r>
           </a:p>
           <a:p>
@@ -18076,155 +18192,7 @@
                 </a:solidFill>
                 <a:latin typeface="Arial"/>
               </a:rPr>
-              <a:t>• /user_seats/{userId}: Owner/Admin read; Admin-only write.</a:t>
-            </a:r>
-          </a:p>
-        </p:txBody>
-      </p:sp>
-      <p:sp>
-        <p:nvSpPr>
-          <p:cNvPr id="28" name="Card_1"/>
-          <p:cNvSpPr/>
-          <p:nvPr/>
-        </p:nvSpPr>
-        <p:spPr>
-          <a:xfrm>
-            <a:off x="6200000" y="3240000"/>
-            <a:ext cx="2720000" cy="2850000"/>
-          </a:xfrm>
-          <a:prstGeom prst="roundRect">
-            <a:avLst>
-              <a:gd name="adj" fmla="val 8000"/>
-            </a:avLst>
-          </a:prstGeom>
-          <a:solidFill>
-            <a:srgbClr val="110E0B"/>
-          </a:solidFill>
-          <a:ln w="12700">
-            <a:solidFill>
-              <a:srgbClr val="45270A"/>
-            </a:solidFill>
-          </a:ln>
-        </p:spPr>
-        <p:txBody>
-          <a:bodyPr wrap="square" lIns="114300" tIns="91440" rIns="114300" bIns="91440" anchor="t"/>
-          <a:lstStyle/>
-          <a:p>
-            <a:pPr algn="l"/>
-            <a:r>
-              <a:rPr lang="en-US" sz="800" b="1" dirty="0">
-                <a:solidFill>
-                  <a:srgbClr val="F59E0B"/>
-                </a:solidFill>
-                <a:latin typeface="Courier New"/>
-              </a:rPr>
-              <a:t>INSURANCE ACT CAP 487 &amp; KRA ETIMS</a:t>
-            </a:r>
-          </a:p>
-          <a:p>
-            <a:pPr algn="l">
-              <a:spcBef>
-                <a:spcPts val="400"/>
-              </a:spcBef>
-            </a:pPr>
-            <a:r>
-              <a:rPr lang="en-US" sz="1250" b="1" dirty="0">
-                <a:solidFill>
-                  <a:srgbClr val="FFFFFF"/>
-                </a:solidFill>
-                <a:latin typeface="Arial"/>
-              </a:rPr>
-              <a:t>Automated Statutory Levy &amp; Tax Remittance</a:t>
-            </a:r>
-          </a:p>
-          <a:p>
-            <a:pPr algn="l">
-              <a:spcBef>
-                <a:spcPts val="500"/>
-              </a:spcBef>
-            </a:pPr>
-            <a:r>
-              <a:rPr lang="en-US" sz="980" b="0" dirty="0">
-                <a:solidFill>
-                  <a:srgbClr val="D4D4D8"/>
-                </a:solidFill>
-                <a:latin typeface="Arial"/>
-              </a:rPr>
-              <a:t>Automatically computes and separates PHCF (0.25%), Training Levy (0.20%), Stamp Duty (KSh 40), 16% VAT (Form VAT 3), and 5% Garage WHT (Form WHT-1) with 1-click KRA iTax batch filing.</a:t>
-            </a:r>
-          </a:p>
-        </p:txBody>
-      </p:sp>
-      <p:sp>
-        <p:nvSpPr>
-          <p:cNvPr id="29" name="Card_2"/>
-          <p:cNvSpPr/>
-          <p:nvPr/>
-        </p:nvSpPr>
-        <p:spPr>
-          <a:xfrm>
-            <a:off x="9100000" y="3240000"/>
-            <a:ext cx="2720000" cy="2850000"/>
-          </a:xfrm>
-          <a:prstGeom prst="roundRect">
-            <a:avLst>
-              <a:gd name="adj" fmla="val 8000"/>
-            </a:avLst>
-          </a:prstGeom>
-          <a:solidFill>
-            <a:srgbClr val="110E0B"/>
-          </a:solidFill>
-          <a:ln w="12700">
-            <a:solidFill>
-              <a:srgbClr val="45270A"/>
-            </a:solidFill>
-          </a:ln>
-        </p:spPr>
-        <p:txBody>
-          <a:bodyPr wrap="square" lIns="114300" tIns="91440" rIns="114300" bIns="91440" anchor="t"/>
-          <a:lstStyle/>
-          <a:p>
-            <a:pPr algn="l"/>
-            <a:r>
-              <a:rPr lang="en-US" sz="800" b="1" dirty="0">
-                <a:solidFill>
-                  <a:srgbClr val="F59E0B"/>
-                </a:solidFill>
-                <a:latin typeface="Courier New"/>
-              </a:rPr>
-              <a:t>E-CITIZEN &amp; PESAFLOW GATEWAY</a:t>
-            </a:r>
-          </a:p>
-          <a:p>
-            <a:pPr algn="l">
-              <a:spcBef>
-                <a:spcPts val="400"/>
-              </a:spcBef>
-            </a:pPr>
-            <a:r>
-              <a:rPr lang="en-US" sz="1250" b="1" dirty="0">
-                <a:solidFill>
-                  <a:srgbClr val="FFFFFF"/>
-                </a:solidFill>
-                <a:latin typeface="Arial"/>
-              </a:rPr>
-              <a:t>Paybill 222222 &amp; Republic of Kenya SSO</a:t>
-            </a:r>
-          </a:p>
-          <a:p>
-            <a:pPr algn="l">
-              <a:spcBef>
-                <a:spcPts val="500"/>
-              </a:spcBef>
-            </a:pPr>
-            <a:r>
-              <a:rPr lang="en-US" sz="980" b="0" dirty="0">
-                <a:solidFill>
-                  <a:srgbClr val="D4D4D8"/>
-                </a:solidFill>
-                <a:latin typeface="Arial"/>
-              </a:rPr>
-              <a:t>Integrated e-Citizen National ID Single Sign-On and PesaFlow Government Payment checkout supporting M-PESA STK Push, Visa/Mastercard, Airtel Money, and KCB/Equity bank slips.</a:t>
+              <a:t>Supports Republic of Kenya e-Citizen National ID Single Sign-On, PesaFlow Government checkout, and sub-30-second M-PESA B2C, Airtel Money, and PesaLink EFT claim disbursements.</a:t>
             </a:r>
           </a:p>
         </p:txBody>

</xml_diff>